<commit_message>
logo: embed Kievo mark (white vector rebuild) on cover + header of slides 2-8
Co-authored-by: arena-agent <297053741+arena-agent@users.noreply.github.com>
</commit_message>
<xml_diff>
--- a/presentation/preorder_new_year_corporate_2025.pptx
+++ b/presentation/preorder_new_year_corporate_2025.pptx
@@ -3618,92 +3618,34 @@
           </a:p>
         </p:txBody>
       </p:sp>
-      <p:sp>
-        <p:nvSpPr>
-          <p:cNvPr id="13" name="Rectangle 12"/>
-          <p:cNvSpPr/>
-          <p:nvPr/>
-        </p:nvSpPr>
-        <p:spPr>
-          <a:xfrm>
-            <a:off x="4818888" y="777240"/>
-            <a:ext cx="2560320" cy="731520"/>
-          </a:xfrm>
-          <a:prstGeom prst="rect">
-            <a:avLst/>
-          </a:prstGeom>
-          <a:noFill/>
-          <a:ln w="12700">
-            <a:solidFill>
-              <a:srgbClr val="D4AF37">
-                <a:alpha val="55000"/>
-              </a:srgbClr>
-            </a:solidFill>
-          </a:ln>
+      <p:pic>
+        <p:nvPicPr>
+          <p:cNvPr id="13" name="Picture 12" descr="logo_white.png"/>
+          <p:cNvPicPr>
+            <a:picLocks noChangeAspect="1"/>
+          </p:cNvPicPr>
+          <p:nvPr/>
+        </p:nvPicPr>
+        <p:blipFill>
+          <a:blip r:embed="rId2"/>
+          <a:stretch>
+            <a:fillRect/>
+          </a:stretch>
+        </p:blipFill>
+        <p:spPr>
+          <a:xfrm>
+            <a:off x="5661507" y="621792"/>
+            <a:ext cx="868680" cy="868680"/>
+          </a:xfrm>
+          <a:prstGeom prst="rect">
+            <a:avLst/>
+          </a:prstGeom>
           <a:effectLst/>
         </p:spPr>
-        <p:style>
-          <a:lnRef idx="1">
-            <a:schemeClr val="accent1"/>
-          </a:lnRef>
-          <a:fillRef idx="3">
-            <a:schemeClr val="accent1"/>
-          </a:fillRef>
-          <a:effectRef idx="2">
-            <a:schemeClr val="accent1"/>
-          </a:effectRef>
-          <a:fontRef idx="minor">
-            <a:schemeClr val="lt1"/>
-          </a:fontRef>
-        </p:style>
-        <p:txBody>
-          <a:bodyPr rtlCol="0" anchor="ctr"/>
-          <a:lstStyle/>
-          <a:p>
-            <a:pPr algn="ctr"/>
-          </a:p>
-        </p:txBody>
-      </p:sp>
-      <p:sp>
-        <p:nvSpPr>
-          <p:cNvPr id="14" name="TextBox 13"/>
-          <p:cNvSpPr txBox="1"/>
-          <p:nvPr/>
-        </p:nvSpPr>
-        <p:spPr>
-          <a:xfrm>
-            <a:off x="4818888" y="777240"/>
-            <a:ext cx="2560320" cy="731520"/>
-          </a:xfrm>
-          <a:prstGeom prst="rect">
-            <a:avLst/>
-          </a:prstGeom>
-          <a:noFill/>
-        </p:spPr>
-        <p:txBody>
-          <a:bodyPr wrap="square" anchor="ctr" lIns="0" rIns="0" tIns="0" bIns="0">
-            <a:spAutoFit/>
-          </a:bodyPr>
-          <a:lstStyle/>
-          <a:p>
-            <a:pPr algn="ctr"/>
-            <a:r>
-              <a:rPr sz="1300" b="1" spc="60000">
-                <a:solidFill>
-                  <a:srgbClr val="FFFFFF">
-                    <a:alpha val="85000"/>
-                  </a:srgbClr>
-                </a:solidFill>
-                <a:latin typeface="Montserrat"/>
-              </a:rPr>
-              <a:t>ЛОГОТИП</a:t>
-            </a:r>
-          </a:p>
-        </p:txBody>
-      </p:sp>
-      <p:sp>
-        <p:nvSpPr>
-          <p:cNvPr id="15" name="Diamond 14"/>
+      </p:pic>
+      <p:sp>
+        <p:nvSpPr>
+          <p:cNvPr id="14" name="Diamond 13"/>
           <p:cNvSpPr/>
           <p:nvPr/>
         </p:nvSpPr>
@@ -3749,7 +3691,7 @@
       </p:sp>
       <p:sp>
         <p:nvSpPr>
-          <p:cNvPr id="16" name="TextBox 15"/>
+          <p:cNvPr id="15" name="TextBox 14"/>
           <p:cNvSpPr txBox="1"/>
           <p:nvPr/>
         </p:nvSpPr>
@@ -3786,7 +3728,7 @@
       </p:sp>
       <p:sp>
         <p:nvSpPr>
-          <p:cNvPr id="17" name="TextBox 16"/>
+          <p:cNvPr id="16" name="TextBox 15"/>
           <p:cNvSpPr txBox="1"/>
           <p:nvPr/>
         </p:nvSpPr>
@@ -3841,7 +3783,7 @@
       </p:sp>
       <p:sp>
         <p:nvSpPr>
-          <p:cNvPr id="18" name="TextBox 17"/>
+          <p:cNvPr id="17" name="TextBox 16"/>
           <p:cNvSpPr txBox="1"/>
           <p:nvPr/>
         </p:nvSpPr>
@@ -3876,7 +3818,7 @@
       </p:sp>
       <p:sp>
         <p:nvSpPr>
-          <p:cNvPr id="19" name="Rectangle 18"/>
+          <p:cNvPr id="18" name="Rectangle 17"/>
           <p:cNvSpPr/>
           <p:nvPr/>
         </p:nvSpPr>
@@ -3922,7 +3864,7 @@
       </p:sp>
       <p:sp>
         <p:nvSpPr>
-          <p:cNvPr id="20" name="Rounded Rectangle 19"/>
+          <p:cNvPr id="19" name="Rounded Rectangle 18"/>
           <p:cNvSpPr/>
           <p:nvPr/>
         </p:nvSpPr>
@@ -3974,7 +3916,7 @@
       </p:sp>
       <p:sp>
         <p:nvSpPr>
-          <p:cNvPr id="21" name="TextBox 20"/>
+          <p:cNvPr id="20" name="TextBox 19"/>
           <p:cNvSpPr txBox="1"/>
           <p:nvPr/>
         </p:nvSpPr>
@@ -4127,92 +4069,34 @@
           </a:p>
         </p:txBody>
       </p:sp>
-      <p:sp>
-        <p:nvSpPr>
-          <p:cNvPr id="4" name="Rectangle 3"/>
-          <p:cNvSpPr/>
-          <p:nvPr/>
-        </p:nvSpPr>
-        <p:spPr>
-          <a:xfrm>
-            <a:off x="9811512" y="365760"/>
-            <a:ext cx="1554480" cy="475488"/>
-          </a:xfrm>
-          <a:prstGeom prst="rect">
-            <a:avLst/>
-          </a:prstGeom>
-          <a:noFill/>
-          <a:ln w="9525">
-            <a:solidFill>
-              <a:srgbClr val="D4AF37">
-                <a:alpha val="45000"/>
-              </a:srgbClr>
-            </a:solidFill>
-          </a:ln>
+      <p:pic>
+        <p:nvPicPr>
+          <p:cNvPr id="4" name="Picture 3" descr="logo_white.png"/>
+          <p:cNvPicPr>
+            <a:picLocks noChangeAspect="1"/>
+          </p:cNvPicPr>
+          <p:nvPr/>
+        </p:nvPicPr>
+        <p:blipFill>
+          <a:blip r:embed="rId2"/>
+          <a:stretch>
+            <a:fillRect/>
+          </a:stretch>
+        </p:blipFill>
+        <p:spPr>
+          <a:xfrm>
+            <a:off x="11000232" y="384048"/>
+            <a:ext cx="365760" cy="365760"/>
+          </a:xfrm>
+          <a:prstGeom prst="rect">
+            <a:avLst/>
+          </a:prstGeom>
           <a:effectLst/>
         </p:spPr>
-        <p:style>
-          <a:lnRef idx="1">
-            <a:schemeClr val="accent1"/>
-          </a:lnRef>
-          <a:fillRef idx="3">
-            <a:schemeClr val="accent1"/>
-          </a:fillRef>
-          <a:effectRef idx="2">
-            <a:schemeClr val="accent1"/>
-          </a:effectRef>
-          <a:fontRef idx="minor">
-            <a:schemeClr val="lt1"/>
-          </a:fontRef>
-        </p:style>
-        <p:txBody>
-          <a:bodyPr rtlCol="0" anchor="ctr"/>
-          <a:lstStyle/>
-          <a:p>
-            <a:pPr algn="ctr"/>
-          </a:p>
-        </p:txBody>
-      </p:sp>
-      <p:sp>
-        <p:nvSpPr>
-          <p:cNvPr id="5" name="TextBox 4"/>
-          <p:cNvSpPr txBox="1"/>
-          <p:nvPr/>
-        </p:nvSpPr>
-        <p:spPr>
-          <a:xfrm>
-            <a:off x="9811512" y="365760"/>
-            <a:ext cx="1554480" cy="475488"/>
-          </a:xfrm>
-          <a:prstGeom prst="rect">
-            <a:avLst/>
-          </a:prstGeom>
-          <a:noFill/>
-        </p:spPr>
-        <p:txBody>
-          <a:bodyPr wrap="square" anchor="ctr" lIns="0" rIns="0" tIns="0" bIns="0">
-            <a:spAutoFit/>
-          </a:bodyPr>
-          <a:lstStyle/>
-          <a:p>
-            <a:pPr algn="ctr"/>
-            <a:r>
-              <a:rPr sz="750" b="1" spc="40000">
-                <a:solidFill>
-                  <a:srgbClr val="A0AEC0">
-                    <a:alpha val="85000"/>
-                  </a:srgbClr>
-                </a:solidFill>
-                <a:latin typeface="Montserrat"/>
-              </a:rPr>
-              <a:t>ЛОГОТИП</a:t>
-            </a:r>
-          </a:p>
-        </p:txBody>
-      </p:sp>
-      <p:sp>
-        <p:nvSpPr>
-          <p:cNvPr id="6" name="Rectangle 5"/>
+      </p:pic>
+      <p:sp>
+        <p:nvSpPr>
+          <p:cNvPr id="5" name="Rectangle 4"/>
           <p:cNvSpPr/>
           <p:nvPr/>
         </p:nvSpPr>
@@ -4258,7 +4142,7 @@
       </p:sp>
       <p:sp>
         <p:nvSpPr>
-          <p:cNvPr id="7" name="Rectangle 6"/>
+          <p:cNvPr id="6" name="Rectangle 5"/>
           <p:cNvSpPr/>
           <p:nvPr/>
         </p:nvSpPr>
@@ -4304,7 +4188,7 @@
       </p:sp>
       <p:sp>
         <p:nvSpPr>
-          <p:cNvPr id="8" name="TextBox 7"/>
+          <p:cNvPr id="7" name="TextBox 6"/>
           <p:cNvSpPr txBox="1"/>
           <p:nvPr/>
         </p:nvSpPr>
@@ -4341,7 +4225,7 @@
       </p:sp>
       <p:sp>
         <p:nvSpPr>
-          <p:cNvPr id="9" name="TextBox 8"/>
+          <p:cNvPr id="8" name="TextBox 7"/>
           <p:cNvSpPr txBox="1"/>
           <p:nvPr/>
         </p:nvSpPr>
@@ -4378,7 +4262,7 @@
       </p:sp>
       <p:sp>
         <p:nvSpPr>
-          <p:cNvPr id="10" name="TextBox 9"/>
+          <p:cNvPr id="9" name="TextBox 8"/>
           <p:cNvSpPr txBox="1"/>
           <p:nvPr/>
         </p:nvSpPr>
@@ -4415,7 +4299,7 @@
       </p:sp>
       <p:sp>
         <p:nvSpPr>
-          <p:cNvPr id="11" name="Diamond 10"/>
+          <p:cNvPr id="10" name="Diamond 9"/>
           <p:cNvSpPr/>
           <p:nvPr/>
         </p:nvSpPr>
@@ -4461,7 +4345,7 @@
       </p:sp>
       <p:sp>
         <p:nvSpPr>
-          <p:cNvPr id="12" name="TextBox 11"/>
+          <p:cNvPr id="11" name="TextBox 10"/>
           <p:cNvSpPr txBox="1"/>
           <p:nvPr/>
         </p:nvSpPr>
@@ -4496,7 +4380,7 @@
       </p:sp>
       <p:sp>
         <p:nvSpPr>
-          <p:cNvPr id="13" name="TextBox 12"/>
+          <p:cNvPr id="12" name="TextBox 11"/>
           <p:cNvSpPr txBox="1"/>
           <p:nvPr/>
         </p:nvSpPr>
@@ -4535,7 +4419,7 @@
       </p:sp>
       <p:sp>
         <p:nvSpPr>
-          <p:cNvPr id="14" name="TextBox 13"/>
+          <p:cNvPr id="13" name="TextBox 12"/>
           <p:cNvSpPr txBox="1"/>
           <p:nvPr/>
         </p:nvSpPr>
@@ -4574,7 +4458,7 @@
       </p:sp>
       <p:sp>
         <p:nvSpPr>
-          <p:cNvPr id="15" name="Rounded Rectangle 14"/>
+          <p:cNvPr id="14" name="Rounded Rectangle 13"/>
           <p:cNvSpPr/>
           <p:nvPr/>
         </p:nvSpPr>
@@ -4626,7 +4510,7 @@
       </p:sp>
       <p:sp>
         <p:nvSpPr>
-          <p:cNvPr id="16" name="Rectangle 15"/>
+          <p:cNvPr id="15" name="Rectangle 14"/>
           <p:cNvSpPr/>
           <p:nvPr/>
         </p:nvSpPr>
@@ -4672,7 +4556,7 @@
       </p:sp>
       <p:sp>
         <p:nvSpPr>
-          <p:cNvPr id="17" name="TextBox 16"/>
+          <p:cNvPr id="16" name="TextBox 15"/>
           <p:cNvSpPr txBox="1"/>
           <p:nvPr/>
         </p:nvSpPr>
@@ -4709,7 +4593,7 @@
       </p:sp>
       <p:sp>
         <p:nvSpPr>
-          <p:cNvPr id="18" name="Rounded Rectangle 17"/>
+          <p:cNvPr id="17" name="Rounded Rectangle 16"/>
           <p:cNvSpPr/>
           <p:nvPr/>
         </p:nvSpPr>
@@ -4761,7 +4645,7 @@
       </p:sp>
       <p:sp>
         <p:nvSpPr>
-          <p:cNvPr id="19" name="TextBox 18"/>
+          <p:cNvPr id="18" name="TextBox 17"/>
           <p:cNvSpPr txBox="1"/>
           <p:nvPr/>
         </p:nvSpPr>
@@ -4798,7 +4682,7 @@
       </p:sp>
       <p:sp>
         <p:nvSpPr>
-          <p:cNvPr id="20" name="Rounded Rectangle 19"/>
+          <p:cNvPr id="19" name="Rounded Rectangle 18"/>
           <p:cNvSpPr/>
           <p:nvPr/>
         </p:nvSpPr>
@@ -4850,7 +4734,7 @@
       </p:sp>
       <p:sp>
         <p:nvSpPr>
-          <p:cNvPr id="21" name="TextBox 20"/>
+          <p:cNvPr id="20" name="TextBox 19"/>
           <p:cNvSpPr txBox="1"/>
           <p:nvPr/>
         </p:nvSpPr>
@@ -4887,7 +4771,7 @@
       </p:sp>
       <p:sp>
         <p:nvSpPr>
-          <p:cNvPr id="22" name="Rounded Rectangle 21"/>
+          <p:cNvPr id="21" name="Rounded Rectangle 20"/>
           <p:cNvSpPr/>
           <p:nvPr/>
         </p:nvSpPr>
@@ -4939,7 +4823,7 @@
       </p:sp>
       <p:sp>
         <p:nvSpPr>
-          <p:cNvPr id="23" name="TextBox 22"/>
+          <p:cNvPr id="22" name="TextBox 21"/>
           <p:cNvSpPr txBox="1"/>
           <p:nvPr/>
         </p:nvSpPr>
@@ -4976,7 +4860,7 @@
       </p:sp>
       <p:sp>
         <p:nvSpPr>
-          <p:cNvPr id="24" name="Rounded Rectangle 23"/>
+          <p:cNvPr id="23" name="Rounded Rectangle 22"/>
           <p:cNvSpPr/>
           <p:nvPr/>
         </p:nvSpPr>
@@ -5028,7 +4912,7 @@
       </p:sp>
       <p:sp>
         <p:nvSpPr>
-          <p:cNvPr id="25" name="TextBox 24"/>
+          <p:cNvPr id="24" name="TextBox 23"/>
           <p:cNvSpPr txBox="1"/>
           <p:nvPr/>
         </p:nvSpPr>
@@ -5065,7 +4949,7 @@
       </p:sp>
       <p:sp>
         <p:nvSpPr>
-          <p:cNvPr id="26" name="Rounded Rectangle 25"/>
+          <p:cNvPr id="25" name="Rounded Rectangle 24"/>
           <p:cNvSpPr/>
           <p:nvPr/>
         </p:nvSpPr>
@@ -5117,7 +5001,7 @@
       </p:sp>
       <p:sp>
         <p:nvSpPr>
-          <p:cNvPr id="27" name="TextBox 26"/>
+          <p:cNvPr id="26" name="TextBox 25"/>
           <p:cNvSpPr txBox="1"/>
           <p:nvPr/>
         </p:nvSpPr>
@@ -5154,7 +5038,7 @@
       </p:sp>
       <p:sp>
         <p:nvSpPr>
-          <p:cNvPr id="28" name="Rounded Rectangle 27"/>
+          <p:cNvPr id="27" name="Rounded Rectangle 26"/>
           <p:cNvSpPr/>
           <p:nvPr/>
         </p:nvSpPr>
@@ -5206,7 +5090,7 @@
       </p:sp>
       <p:sp>
         <p:nvSpPr>
-          <p:cNvPr id="29" name="TextBox 28"/>
+          <p:cNvPr id="28" name="TextBox 27"/>
           <p:cNvSpPr txBox="1"/>
           <p:nvPr/>
         </p:nvSpPr>
@@ -5243,7 +5127,7 @@
       </p:sp>
       <p:sp>
         <p:nvSpPr>
-          <p:cNvPr id="30" name="Rounded Rectangle 29"/>
+          <p:cNvPr id="29" name="Rounded Rectangle 28"/>
           <p:cNvSpPr/>
           <p:nvPr/>
         </p:nvSpPr>
@@ -5295,7 +5179,7 @@
       </p:sp>
       <p:sp>
         <p:nvSpPr>
-          <p:cNvPr id="31" name="TextBox 30"/>
+          <p:cNvPr id="30" name="TextBox 29"/>
           <p:cNvSpPr txBox="1"/>
           <p:nvPr/>
         </p:nvSpPr>
@@ -5332,7 +5216,7 @@
       </p:sp>
       <p:sp>
         <p:nvSpPr>
-          <p:cNvPr id="32" name="Rounded Rectangle 31"/>
+          <p:cNvPr id="31" name="Rounded Rectangle 30"/>
           <p:cNvSpPr/>
           <p:nvPr/>
         </p:nvSpPr>
@@ -5384,7 +5268,7 @@
       </p:sp>
       <p:sp>
         <p:nvSpPr>
-          <p:cNvPr id="33" name="TextBox 32"/>
+          <p:cNvPr id="32" name="TextBox 31"/>
           <p:cNvSpPr txBox="1"/>
           <p:nvPr/>
         </p:nvSpPr>
@@ -5419,7 +5303,7 @@
       </p:sp>
       <p:sp>
         <p:nvSpPr>
-          <p:cNvPr id="34" name="TextBox 33"/>
+          <p:cNvPr id="33" name="TextBox 32"/>
           <p:cNvSpPr txBox="1"/>
           <p:nvPr/>
         </p:nvSpPr>
@@ -5460,7 +5344,7 @@
       </p:sp>
       <p:sp>
         <p:nvSpPr>
-          <p:cNvPr id="35" name="Rounded Rectangle 34"/>
+          <p:cNvPr id="34" name="Rounded Rectangle 33"/>
           <p:cNvSpPr/>
           <p:nvPr/>
         </p:nvSpPr>
@@ -5512,7 +5396,7 @@
       </p:sp>
       <p:sp>
         <p:nvSpPr>
-          <p:cNvPr id="36" name="TextBox 35"/>
+          <p:cNvPr id="35" name="TextBox 34"/>
           <p:cNvSpPr txBox="1"/>
           <p:nvPr/>
         </p:nvSpPr>
@@ -5679,92 +5563,34 @@
           </a:p>
         </p:txBody>
       </p:sp>
-      <p:sp>
-        <p:nvSpPr>
-          <p:cNvPr id="4" name="Rectangle 3"/>
-          <p:cNvSpPr/>
-          <p:nvPr/>
-        </p:nvSpPr>
-        <p:spPr>
-          <a:xfrm>
-            <a:off x="9811512" y="365760"/>
-            <a:ext cx="1554480" cy="475488"/>
-          </a:xfrm>
-          <a:prstGeom prst="rect">
-            <a:avLst/>
-          </a:prstGeom>
-          <a:noFill/>
-          <a:ln w="9525">
-            <a:solidFill>
-              <a:srgbClr val="D4AF37">
-                <a:alpha val="45000"/>
-              </a:srgbClr>
-            </a:solidFill>
-          </a:ln>
+      <p:pic>
+        <p:nvPicPr>
+          <p:cNvPr id="4" name="Picture 3" descr="logo_white.png"/>
+          <p:cNvPicPr>
+            <a:picLocks noChangeAspect="1"/>
+          </p:cNvPicPr>
+          <p:nvPr/>
+        </p:nvPicPr>
+        <p:blipFill>
+          <a:blip r:embed="rId2"/>
+          <a:stretch>
+            <a:fillRect/>
+          </a:stretch>
+        </p:blipFill>
+        <p:spPr>
+          <a:xfrm>
+            <a:off x="11000232" y="384048"/>
+            <a:ext cx="365760" cy="365760"/>
+          </a:xfrm>
+          <a:prstGeom prst="rect">
+            <a:avLst/>
+          </a:prstGeom>
           <a:effectLst/>
         </p:spPr>
-        <p:style>
-          <a:lnRef idx="1">
-            <a:schemeClr val="accent1"/>
-          </a:lnRef>
-          <a:fillRef idx="3">
-            <a:schemeClr val="accent1"/>
-          </a:fillRef>
-          <a:effectRef idx="2">
-            <a:schemeClr val="accent1"/>
-          </a:effectRef>
-          <a:fontRef idx="minor">
-            <a:schemeClr val="lt1"/>
-          </a:fontRef>
-        </p:style>
-        <p:txBody>
-          <a:bodyPr rtlCol="0" anchor="ctr"/>
-          <a:lstStyle/>
-          <a:p>
-            <a:pPr algn="ctr"/>
-          </a:p>
-        </p:txBody>
-      </p:sp>
-      <p:sp>
-        <p:nvSpPr>
-          <p:cNvPr id="5" name="TextBox 4"/>
-          <p:cNvSpPr txBox="1"/>
-          <p:nvPr/>
-        </p:nvSpPr>
-        <p:spPr>
-          <a:xfrm>
-            <a:off x="9811512" y="365760"/>
-            <a:ext cx="1554480" cy="475488"/>
-          </a:xfrm>
-          <a:prstGeom prst="rect">
-            <a:avLst/>
-          </a:prstGeom>
-          <a:noFill/>
-        </p:spPr>
-        <p:txBody>
-          <a:bodyPr wrap="square" anchor="ctr" lIns="0" rIns="0" tIns="0" bIns="0">
-            <a:spAutoFit/>
-          </a:bodyPr>
-          <a:lstStyle/>
-          <a:p>
-            <a:pPr algn="ctr"/>
-            <a:r>
-              <a:rPr sz="750" b="1" spc="40000">
-                <a:solidFill>
-                  <a:srgbClr val="A0AEC0">
-                    <a:alpha val="85000"/>
-                  </a:srgbClr>
-                </a:solidFill>
-                <a:latin typeface="Montserrat"/>
-              </a:rPr>
-              <a:t>ЛОГОТИП</a:t>
-            </a:r>
-          </a:p>
-        </p:txBody>
-      </p:sp>
-      <p:sp>
-        <p:nvSpPr>
-          <p:cNvPr id="6" name="Rectangle 5"/>
+      </p:pic>
+      <p:sp>
+        <p:nvSpPr>
+          <p:cNvPr id="5" name="Rectangle 4"/>
           <p:cNvSpPr/>
           <p:nvPr/>
         </p:nvSpPr>
@@ -5810,7 +5636,7 @@
       </p:sp>
       <p:sp>
         <p:nvSpPr>
-          <p:cNvPr id="7" name="Rectangle 6"/>
+          <p:cNvPr id="6" name="Rectangle 5"/>
           <p:cNvSpPr/>
           <p:nvPr/>
         </p:nvSpPr>
@@ -5856,7 +5682,7 @@
       </p:sp>
       <p:sp>
         <p:nvSpPr>
-          <p:cNvPr id="8" name="TextBox 7"/>
+          <p:cNvPr id="7" name="TextBox 6"/>
           <p:cNvSpPr txBox="1"/>
           <p:nvPr/>
         </p:nvSpPr>
@@ -5893,7 +5719,7 @@
       </p:sp>
       <p:sp>
         <p:nvSpPr>
-          <p:cNvPr id="9" name="TextBox 8"/>
+          <p:cNvPr id="8" name="TextBox 7"/>
           <p:cNvSpPr txBox="1"/>
           <p:nvPr/>
         </p:nvSpPr>
@@ -5930,7 +5756,7 @@
       </p:sp>
       <p:sp>
         <p:nvSpPr>
-          <p:cNvPr id="10" name="TextBox 9"/>
+          <p:cNvPr id="9" name="TextBox 8"/>
           <p:cNvSpPr txBox="1"/>
           <p:nvPr/>
         </p:nvSpPr>
@@ -5967,7 +5793,7 @@
       </p:sp>
       <p:sp>
         <p:nvSpPr>
-          <p:cNvPr id="11" name="Diamond 10"/>
+          <p:cNvPr id="10" name="Diamond 9"/>
           <p:cNvSpPr/>
           <p:nvPr/>
         </p:nvSpPr>
@@ -6013,7 +5839,7 @@
       </p:sp>
       <p:sp>
         <p:nvSpPr>
-          <p:cNvPr id="12" name="TextBox 11"/>
+          <p:cNvPr id="11" name="TextBox 10"/>
           <p:cNvSpPr txBox="1"/>
           <p:nvPr/>
         </p:nvSpPr>
@@ -6048,7 +5874,7 @@
       </p:sp>
       <p:sp>
         <p:nvSpPr>
-          <p:cNvPr id="13" name="TextBox 12"/>
+          <p:cNvPr id="12" name="TextBox 11"/>
           <p:cNvSpPr txBox="1"/>
           <p:nvPr/>
         </p:nvSpPr>
@@ -6087,7 +5913,7 @@
       </p:sp>
       <p:sp>
         <p:nvSpPr>
-          <p:cNvPr id="14" name="TextBox 13"/>
+          <p:cNvPr id="13" name="TextBox 12"/>
           <p:cNvSpPr txBox="1"/>
           <p:nvPr/>
         </p:nvSpPr>
@@ -6126,7 +5952,7 @@
       </p:sp>
       <p:sp>
         <p:nvSpPr>
-          <p:cNvPr id="15" name="Diamond 14"/>
+          <p:cNvPr id="14" name="Diamond 13"/>
           <p:cNvSpPr/>
           <p:nvPr/>
         </p:nvSpPr>
@@ -6172,7 +5998,7 @@
       </p:sp>
       <p:sp>
         <p:nvSpPr>
-          <p:cNvPr id="16" name="Oval 15"/>
+          <p:cNvPr id="15" name="Oval 14"/>
           <p:cNvSpPr/>
           <p:nvPr/>
         </p:nvSpPr>
@@ -6222,7 +6048,7 @@
       </p:sp>
       <p:sp>
         <p:nvSpPr>
-          <p:cNvPr id="17" name="Oval 16"/>
+          <p:cNvPr id="16" name="Oval 15"/>
           <p:cNvSpPr/>
           <p:nvPr/>
         </p:nvSpPr>
@@ -6269,7 +6095,7 @@
       </p:sp>
       <p:sp>
         <p:nvSpPr>
-          <p:cNvPr id="18" name="TextBox 17"/>
+          <p:cNvPr id="17" name="TextBox 16"/>
           <p:cNvSpPr txBox="1"/>
           <p:nvPr/>
         </p:nvSpPr>
@@ -6306,7 +6132,7 @@
       </p:sp>
       <p:sp>
         <p:nvSpPr>
-          <p:cNvPr id="19" name="TextBox 18"/>
+          <p:cNvPr id="18" name="TextBox 17"/>
           <p:cNvSpPr txBox="1"/>
           <p:nvPr/>
         </p:nvSpPr>
@@ -6341,7 +6167,7 @@
       </p:sp>
       <p:sp>
         <p:nvSpPr>
-          <p:cNvPr id="20" name="TextBox 19"/>
+          <p:cNvPr id="19" name="TextBox 18"/>
           <p:cNvSpPr txBox="1"/>
           <p:nvPr/>
         </p:nvSpPr>
@@ -6376,7 +6202,7 @@
       </p:sp>
       <p:sp>
         <p:nvSpPr>
-          <p:cNvPr id="21" name="TextBox 20"/>
+          <p:cNvPr id="20" name="TextBox 19"/>
           <p:cNvSpPr txBox="1"/>
           <p:nvPr/>
         </p:nvSpPr>
@@ -6529,92 +6355,34 @@
           </a:p>
         </p:txBody>
       </p:sp>
-      <p:sp>
-        <p:nvSpPr>
-          <p:cNvPr id="4" name="Rectangle 3"/>
-          <p:cNvSpPr/>
-          <p:nvPr/>
-        </p:nvSpPr>
-        <p:spPr>
-          <a:xfrm>
-            <a:off x="9811512" y="365760"/>
-            <a:ext cx="1554480" cy="475488"/>
-          </a:xfrm>
-          <a:prstGeom prst="rect">
-            <a:avLst/>
-          </a:prstGeom>
-          <a:noFill/>
-          <a:ln w="9525">
-            <a:solidFill>
-              <a:srgbClr val="D4AF37">
-                <a:alpha val="45000"/>
-              </a:srgbClr>
-            </a:solidFill>
-          </a:ln>
+      <p:pic>
+        <p:nvPicPr>
+          <p:cNvPr id="4" name="Picture 3" descr="logo_white.png"/>
+          <p:cNvPicPr>
+            <a:picLocks noChangeAspect="1"/>
+          </p:cNvPicPr>
+          <p:nvPr/>
+        </p:nvPicPr>
+        <p:blipFill>
+          <a:blip r:embed="rId2"/>
+          <a:stretch>
+            <a:fillRect/>
+          </a:stretch>
+        </p:blipFill>
+        <p:spPr>
+          <a:xfrm>
+            <a:off x="11000232" y="384048"/>
+            <a:ext cx="365760" cy="365760"/>
+          </a:xfrm>
+          <a:prstGeom prst="rect">
+            <a:avLst/>
+          </a:prstGeom>
           <a:effectLst/>
         </p:spPr>
-        <p:style>
-          <a:lnRef idx="1">
-            <a:schemeClr val="accent1"/>
-          </a:lnRef>
-          <a:fillRef idx="3">
-            <a:schemeClr val="accent1"/>
-          </a:fillRef>
-          <a:effectRef idx="2">
-            <a:schemeClr val="accent1"/>
-          </a:effectRef>
-          <a:fontRef idx="minor">
-            <a:schemeClr val="lt1"/>
-          </a:fontRef>
-        </p:style>
-        <p:txBody>
-          <a:bodyPr rtlCol="0" anchor="ctr"/>
-          <a:lstStyle/>
-          <a:p>
-            <a:pPr algn="ctr"/>
-          </a:p>
-        </p:txBody>
-      </p:sp>
-      <p:sp>
-        <p:nvSpPr>
-          <p:cNvPr id="5" name="TextBox 4"/>
-          <p:cNvSpPr txBox="1"/>
-          <p:nvPr/>
-        </p:nvSpPr>
-        <p:spPr>
-          <a:xfrm>
-            <a:off x="9811512" y="365760"/>
-            <a:ext cx="1554480" cy="475488"/>
-          </a:xfrm>
-          <a:prstGeom prst="rect">
-            <a:avLst/>
-          </a:prstGeom>
-          <a:noFill/>
-        </p:spPr>
-        <p:txBody>
-          <a:bodyPr wrap="square" anchor="ctr" lIns="0" rIns="0" tIns="0" bIns="0">
-            <a:spAutoFit/>
-          </a:bodyPr>
-          <a:lstStyle/>
-          <a:p>
-            <a:pPr algn="ctr"/>
-            <a:r>
-              <a:rPr sz="750" b="1" spc="40000">
-                <a:solidFill>
-                  <a:srgbClr val="A0AEC0">
-                    <a:alpha val="85000"/>
-                  </a:srgbClr>
-                </a:solidFill>
-                <a:latin typeface="Montserrat"/>
-              </a:rPr>
-              <a:t>ЛОГОТИП</a:t>
-            </a:r>
-          </a:p>
-        </p:txBody>
-      </p:sp>
-      <p:sp>
-        <p:nvSpPr>
-          <p:cNvPr id="6" name="Rectangle 5"/>
+      </p:pic>
+      <p:sp>
+        <p:nvSpPr>
+          <p:cNvPr id="5" name="Rectangle 4"/>
           <p:cNvSpPr/>
           <p:nvPr/>
         </p:nvSpPr>
@@ -6660,7 +6428,7 @@
       </p:sp>
       <p:sp>
         <p:nvSpPr>
-          <p:cNvPr id="7" name="Rectangle 6"/>
+          <p:cNvPr id="6" name="Rectangle 5"/>
           <p:cNvSpPr/>
           <p:nvPr/>
         </p:nvSpPr>
@@ -6706,7 +6474,7 @@
       </p:sp>
       <p:sp>
         <p:nvSpPr>
-          <p:cNvPr id="8" name="TextBox 7"/>
+          <p:cNvPr id="7" name="TextBox 6"/>
           <p:cNvSpPr txBox="1"/>
           <p:nvPr/>
         </p:nvSpPr>
@@ -6743,7 +6511,7 @@
       </p:sp>
       <p:sp>
         <p:nvSpPr>
-          <p:cNvPr id="9" name="TextBox 8"/>
+          <p:cNvPr id="8" name="TextBox 7"/>
           <p:cNvSpPr txBox="1"/>
           <p:nvPr/>
         </p:nvSpPr>
@@ -6780,7 +6548,7 @@
       </p:sp>
       <p:sp>
         <p:nvSpPr>
-          <p:cNvPr id="10" name="TextBox 9"/>
+          <p:cNvPr id="9" name="TextBox 8"/>
           <p:cNvSpPr txBox="1"/>
           <p:nvPr/>
         </p:nvSpPr>
@@ -6817,7 +6585,7 @@
       </p:sp>
       <p:sp>
         <p:nvSpPr>
-          <p:cNvPr id="11" name="Diamond 10"/>
+          <p:cNvPr id="10" name="Diamond 9"/>
           <p:cNvSpPr/>
           <p:nvPr/>
         </p:nvSpPr>
@@ -6863,7 +6631,7 @@
       </p:sp>
       <p:sp>
         <p:nvSpPr>
-          <p:cNvPr id="12" name="TextBox 11"/>
+          <p:cNvPr id="11" name="TextBox 10"/>
           <p:cNvSpPr txBox="1"/>
           <p:nvPr/>
         </p:nvSpPr>
@@ -6898,7 +6666,7 @@
       </p:sp>
       <p:sp>
         <p:nvSpPr>
-          <p:cNvPr id="13" name="TextBox 12"/>
+          <p:cNvPr id="12" name="TextBox 11"/>
           <p:cNvSpPr txBox="1"/>
           <p:nvPr/>
         </p:nvSpPr>
@@ -6937,7 +6705,7 @@
       </p:sp>
       <p:sp>
         <p:nvSpPr>
-          <p:cNvPr id="14" name="TextBox 13"/>
+          <p:cNvPr id="13" name="TextBox 12"/>
           <p:cNvSpPr txBox="1"/>
           <p:nvPr/>
         </p:nvSpPr>
@@ -6976,7 +6744,7 @@
       </p:sp>
       <p:sp>
         <p:nvSpPr>
-          <p:cNvPr id="15" name="TextBox 14"/>
+          <p:cNvPr id="14" name="TextBox 13"/>
           <p:cNvSpPr txBox="1"/>
           <p:nvPr/>
         </p:nvSpPr>
@@ -7013,7 +6781,7 @@
       </p:sp>
       <p:sp>
         <p:nvSpPr>
-          <p:cNvPr id="16" name="Rounded Rectangle 15"/>
+          <p:cNvPr id="15" name="Rounded Rectangle 14"/>
           <p:cNvSpPr/>
           <p:nvPr/>
         </p:nvSpPr>
@@ -7065,7 +6833,7 @@
       </p:sp>
       <p:sp>
         <p:nvSpPr>
-          <p:cNvPr id="17" name="Rectangle 16"/>
+          <p:cNvPr id="16" name="Rectangle 15"/>
           <p:cNvSpPr/>
           <p:nvPr/>
         </p:nvSpPr>
@@ -7111,7 +6879,7 @@
       </p:sp>
       <p:sp>
         <p:nvSpPr>
-          <p:cNvPr id="18" name="TextBox 17"/>
+          <p:cNvPr id="17" name="TextBox 16"/>
           <p:cNvSpPr txBox="1"/>
           <p:nvPr/>
         </p:nvSpPr>
@@ -7146,7 +6914,7 @@
       </p:sp>
       <p:sp>
         <p:nvSpPr>
-          <p:cNvPr id="19" name="TextBox 18"/>
+          <p:cNvPr id="18" name="TextBox 17"/>
           <p:cNvSpPr txBox="1"/>
           <p:nvPr/>
         </p:nvSpPr>
@@ -7181,7 +6949,7 @@
       </p:sp>
       <p:sp>
         <p:nvSpPr>
-          <p:cNvPr id="20" name="TextBox 19"/>
+          <p:cNvPr id="19" name="TextBox 18"/>
           <p:cNvSpPr txBox="1"/>
           <p:nvPr/>
         </p:nvSpPr>
@@ -7218,7 +6986,7 @@
       </p:sp>
       <p:sp>
         <p:nvSpPr>
-          <p:cNvPr id="21" name="Rounded Rectangle 20"/>
+          <p:cNvPr id="20" name="Rounded Rectangle 19"/>
           <p:cNvSpPr/>
           <p:nvPr/>
         </p:nvSpPr>
@@ -7270,7 +7038,7 @@
       </p:sp>
       <p:sp>
         <p:nvSpPr>
-          <p:cNvPr id="22" name="Rectangle 21"/>
+          <p:cNvPr id="21" name="Rectangle 20"/>
           <p:cNvSpPr/>
           <p:nvPr/>
         </p:nvSpPr>
@@ -7316,7 +7084,7 @@
       </p:sp>
       <p:sp>
         <p:nvSpPr>
-          <p:cNvPr id="23" name="TextBox 22"/>
+          <p:cNvPr id="22" name="TextBox 21"/>
           <p:cNvSpPr txBox="1"/>
           <p:nvPr/>
         </p:nvSpPr>
@@ -7351,7 +7119,7 @@
       </p:sp>
       <p:sp>
         <p:nvSpPr>
-          <p:cNvPr id="24" name="TextBox 23"/>
+          <p:cNvPr id="23" name="TextBox 22"/>
           <p:cNvSpPr txBox="1"/>
           <p:nvPr/>
         </p:nvSpPr>
@@ -7386,7 +7154,7 @@
       </p:sp>
       <p:sp>
         <p:nvSpPr>
-          <p:cNvPr id="25" name="TextBox 24"/>
+          <p:cNvPr id="24" name="TextBox 23"/>
           <p:cNvSpPr txBox="1"/>
           <p:nvPr/>
         </p:nvSpPr>
@@ -7423,7 +7191,7 @@
       </p:sp>
       <p:sp>
         <p:nvSpPr>
-          <p:cNvPr id="26" name="Rounded Rectangle 25"/>
+          <p:cNvPr id="25" name="Rounded Rectangle 24"/>
           <p:cNvSpPr/>
           <p:nvPr/>
         </p:nvSpPr>
@@ -7475,7 +7243,7 @@
       </p:sp>
       <p:sp>
         <p:nvSpPr>
-          <p:cNvPr id="27" name="Rectangle 26"/>
+          <p:cNvPr id="26" name="Rectangle 25"/>
           <p:cNvSpPr/>
           <p:nvPr/>
         </p:nvSpPr>
@@ -7521,7 +7289,7 @@
       </p:sp>
       <p:sp>
         <p:nvSpPr>
-          <p:cNvPr id="28" name="TextBox 27"/>
+          <p:cNvPr id="27" name="TextBox 26"/>
           <p:cNvSpPr txBox="1"/>
           <p:nvPr/>
         </p:nvSpPr>
@@ -7556,7 +7324,7 @@
       </p:sp>
       <p:sp>
         <p:nvSpPr>
-          <p:cNvPr id="29" name="TextBox 28"/>
+          <p:cNvPr id="28" name="TextBox 27"/>
           <p:cNvSpPr txBox="1"/>
           <p:nvPr/>
         </p:nvSpPr>
@@ -7591,7 +7359,7 @@
       </p:sp>
       <p:sp>
         <p:nvSpPr>
-          <p:cNvPr id="30" name="TextBox 29"/>
+          <p:cNvPr id="29" name="TextBox 28"/>
           <p:cNvSpPr txBox="1"/>
           <p:nvPr/>
         </p:nvSpPr>
@@ -7628,7 +7396,7 @@
       </p:sp>
       <p:sp>
         <p:nvSpPr>
-          <p:cNvPr id="31" name="TextBox 30"/>
+          <p:cNvPr id="30" name="TextBox 29"/>
           <p:cNvSpPr txBox="1"/>
           <p:nvPr/>
         </p:nvSpPr>
@@ -7781,92 +7549,34 @@
           </a:p>
         </p:txBody>
       </p:sp>
-      <p:sp>
-        <p:nvSpPr>
-          <p:cNvPr id="4" name="Rectangle 3"/>
-          <p:cNvSpPr/>
-          <p:nvPr/>
-        </p:nvSpPr>
-        <p:spPr>
-          <a:xfrm>
-            <a:off x="9811512" y="365760"/>
-            <a:ext cx="1554480" cy="475488"/>
-          </a:xfrm>
-          <a:prstGeom prst="rect">
-            <a:avLst/>
-          </a:prstGeom>
-          <a:noFill/>
-          <a:ln w="9525">
-            <a:solidFill>
-              <a:srgbClr val="D4AF37">
-                <a:alpha val="45000"/>
-              </a:srgbClr>
-            </a:solidFill>
-          </a:ln>
+      <p:pic>
+        <p:nvPicPr>
+          <p:cNvPr id="4" name="Picture 3" descr="logo_white.png"/>
+          <p:cNvPicPr>
+            <a:picLocks noChangeAspect="1"/>
+          </p:cNvPicPr>
+          <p:nvPr/>
+        </p:nvPicPr>
+        <p:blipFill>
+          <a:blip r:embed="rId2"/>
+          <a:stretch>
+            <a:fillRect/>
+          </a:stretch>
+        </p:blipFill>
+        <p:spPr>
+          <a:xfrm>
+            <a:off x="11000232" y="384048"/>
+            <a:ext cx="365760" cy="365760"/>
+          </a:xfrm>
+          <a:prstGeom prst="rect">
+            <a:avLst/>
+          </a:prstGeom>
           <a:effectLst/>
         </p:spPr>
-        <p:style>
-          <a:lnRef idx="1">
-            <a:schemeClr val="accent1"/>
-          </a:lnRef>
-          <a:fillRef idx="3">
-            <a:schemeClr val="accent1"/>
-          </a:fillRef>
-          <a:effectRef idx="2">
-            <a:schemeClr val="accent1"/>
-          </a:effectRef>
-          <a:fontRef idx="minor">
-            <a:schemeClr val="lt1"/>
-          </a:fontRef>
-        </p:style>
-        <p:txBody>
-          <a:bodyPr rtlCol="0" anchor="ctr"/>
-          <a:lstStyle/>
-          <a:p>
-            <a:pPr algn="ctr"/>
-          </a:p>
-        </p:txBody>
-      </p:sp>
-      <p:sp>
-        <p:nvSpPr>
-          <p:cNvPr id="5" name="TextBox 4"/>
-          <p:cNvSpPr txBox="1"/>
-          <p:nvPr/>
-        </p:nvSpPr>
-        <p:spPr>
-          <a:xfrm>
-            <a:off x="9811512" y="365760"/>
-            <a:ext cx="1554480" cy="475488"/>
-          </a:xfrm>
-          <a:prstGeom prst="rect">
-            <a:avLst/>
-          </a:prstGeom>
-          <a:noFill/>
-        </p:spPr>
-        <p:txBody>
-          <a:bodyPr wrap="square" anchor="ctr" lIns="0" rIns="0" tIns="0" bIns="0">
-            <a:spAutoFit/>
-          </a:bodyPr>
-          <a:lstStyle/>
-          <a:p>
-            <a:pPr algn="ctr"/>
-            <a:r>
-              <a:rPr sz="750" b="1" spc="40000">
-                <a:solidFill>
-                  <a:srgbClr val="A0AEC0">
-                    <a:alpha val="85000"/>
-                  </a:srgbClr>
-                </a:solidFill>
-                <a:latin typeface="Montserrat"/>
-              </a:rPr>
-              <a:t>ЛОГОТИП</a:t>
-            </a:r>
-          </a:p>
-        </p:txBody>
-      </p:sp>
-      <p:sp>
-        <p:nvSpPr>
-          <p:cNvPr id="6" name="Rectangle 5"/>
+      </p:pic>
+      <p:sp>
+        <p:nvSpPr>
+          <p:cNvPr id="5" name="Rectangle 4"/>
           <p:cNvSpPr/>
           <p:nvPr/>
         </p:nvSpPr>
@@ -7912,7 +7622,7 @@
       </p:sp>
       <p:sp>
         <p:nvSpPr>
-          <p:cNvPr id="7" name="Rectangle 6"/>
+          <p:cNvPr id="6" name="Rectangle 5"/>
           <p:cNvSpPr/>
           <p:nvPr/>
         </p:nvSpPr>
@@ -7958,7 +7668,7 @@
       </p:sp>
       <p:sp>
         <p:nvSpPr>
-          <p:cNvPr id="8" name="TextBox 7"/>
+          <p:cNvPr id="7" name="TextBox 6"/>
           <p:cNvSpPr txBox="1"/>
           <p:nvPr/>
         </p:nvSpPr>
@@ -7995,7 +7705,7 @@
       </p:sp>
       <p:sp>
         <p:nvSpPr>
-          <p:cNvPr id="9" name="TextBox 8"/>
+          <p:cNvPr id="8" name="TextBox 7"/>
           <p:cNvSpPr txBox="1"/>
           <p:nvPr/>
         </p:nvSpPr>
@@ -8032,7 +7742,7 @@
       </p:sp>
       <p:sp>
         <p:nvSpPr>
-          <p:cNvPr id="10" name="TextBox 9"/>
+          <p:cNvPr id="9" name="TextBox 8"/>
           <p:cNvSpPr txBox="1"/>
           <p:nvPr/>
         </p:nvSpPr>
@@ -8069,7 +7779,7 @@
       </p:sp>
       <p:sp>
         <p:nvSpPr>
-          <p:cNvPr id="11" name="Diamond 10"/>
+          <p:cNvPr id="10" name="Diamond 9"/>
           <p:cNvSpPr/>
           <p:nvPr/>
         </p:nvSpPr>
@@ -8115,7 +7825,7 @@
       </p:sp>
       <p:sp>
         <p:nvSpPr>
-          <p:cNvPr id="12" name="TextBox 11"/>
+          <p:cNvPr id="11" name="TextBox 10"/>
           <p:cNvSpPr txBox="1"/>
           <p:nvPr/>
         </p:nvSpPr>
@@ -8150,7 +7860,7 @@
       </p:sp>
       <p:sp>
         <p:nvSpPr>
-          <p:cNvPr id="13" name="TextBox 12"/>
+          <p:cNvPr id="12" name="TextBox 11"/>
           <p:cNvSpPr txBox="1"/>
           <p:nvPr/>
         </p:nvSpPr>
@@ -8189,7 +7899,7 @@
       </p:sp>
       <p:sp>
         <p:nvSpPr>
-          <p:cNvPr id="14" name="TextBox 13"/>
+          <p:cNvPr id="13" name="TextBox 12"/>
           <p:cNvSpPr txBox="1"/>
           <p:nvPr/>
         </p:nvSpPr>
@@ -8228,7 +7938,7 @@
       </p:sp>
       <p:sp>
         <p:nvSpPr>
-          <p:cNvPr id="15" name="Rounded Rectangle 14"/>
+          <p:cNvPr id="14" name="Rounded Rectangle 13"/>
           <p:cNvSpPr/>
           <p:nvPr/>
         </p:nvSpPr>
@@ -8280,7 +7990,7 @@
       </p:sp>
       <p:sp>
         <p:nvSpPr>
-          <p:cNvPr id="16" name="Rectangle 15"/>
+          <p:cNvPr id="15" name="Rectangle 14"/>
           <p:cNvSpPr/>
           <p:nvPr/>
         </p:nvSpPr>
@@ -8326,7 +8036,7 @@
       </p:sp>
       <p:sp>
         <p:nvSpPr>
-          <p:cNvPr id="17" name="TextBox 16"/>
+          <p:cNvPr id="16" name="TextBox 15"/>
           <p:cNvSpPr txBox="1"/>
           <p:nvPr/>
         </p:nvSpPr>
@@ -8363,7 +8073,7 @@
       </p:sp>
       <p:sp>
         <p:nvSpPr>
-          <p:cNvPr id="18" name="TextBox 17"/>
+          <p:cNvPr id="17" name="TextBox 16"/>
           <p:cNvSpPr txBox="1"/>
           <p:nvPr/>
         </p:nvSpPr>
@@ -8398,7 +8108,7 @@
       </p:sp>
       <p:sp>
         <p:nvSpPr>
-          <p:cNvPr id="19" name="TextBox 18"/>
+          <p:cNvPr id="18" name="TextBox 17"/>
           <p:cNvSpPr txBox="1"/>
           <p:nvPr/>
         </p:nvSpPr>
@@ -8439,7 +8149,7 @@
       </p:sp>
       <p:sp>
         <p:nvSpPr>
-          <p:cNvPr id="20" name="Rounded Rectangle 19"/>
+          <p:cNvPr id="19" name="Rounded Rectangle 18"/>
           <p:cNvSpPr/>
           <p:nvPr/>
         </p:nvSpPr>
@@ -8487,7 +8197,7 @@
       </p:sp>
       <p:sp>
         <p:nvSpPr>
-          <p:cNvPr id="21" name="Rounded Rectangle 20"/>
+          <p:cNvPr id="20" name="Rounded Rectangle 19"/>
           <p:cNvSpPr/>
           <p:nvPr/>
         </p:nvSpPr>
@@ -8533,7 +8243,7 @@
       </p:sp>
       <p:sp>
         <p:nvSpPr>
-          <p:cNvPr id="22" name="Rectangle 21"/>
+          <p:cNvPr id="21" name="Rectangle 20"/>
           <p:cNvSpPr/>
           <p:nvPr/>
         </p:nvSpPr>
@@ -8579,7 +8289,7 @@
       </p:sp>
       <p:sp>
         <p:nvSpPr>
-          <p:cNvPr id="23" name="TextBox 22"/>
+          <p:cNvPr id="22" name="TextBox 21"/>
           <p:cNvSpPr txBox="1"/>
           <p:nvPr/>
         </p:nvSpPr>
@@ -8616,7 +8326,7 @@
       </p:sp>
       <p:sp>
         <p:nvSpPr>
-          <p:cNvPr id="24" name="TextBox 23"/>
+          <p:cNvPr id="23" name="TextBox 22"/>
           <p:cNvSpPr txBox="1"/>
           <p:nvPr/>
         </p:nvSpPr>
@@ -8651,7 +8361,7 @@
       </p:sp>
       <p:sp>
         <p:nvSpPr>
-          <p:cNvPr id="25" name="TextBox 24"/>
+          <p:cNvPr id="24" name="TextBox 23"/>
           <p:cNvSpPr txBox="1"/>
           <p:nvPr/>
         </p:nvSpPr>
@@ -8688,7 +8398,7 @@
       </p:sp>
       <p:sp>
         <p:nvSpPr>
-          <p:cNvPr id="26" name="TextBox 25"/>
+          <p:cNvPr id="25" name="TextBox 24"/>
           <p:cNvSpPr txBox="1"/>
           <p:nvPr/>
         </p:nvSpPr>
@@ -8729,7 +8439,7 @@
       </p:sp>
       <p:sp>
         <p:nvSpPr>
-          <p:cNvPr id="27" name="Rounded Rectangle 26"/>
+          <p:cNvPr id="26" name="Rounded Rectangle 25"/>
           <p:cNvSpPr/>
           <p:nvPr/>
         </p:nvSpPr>
@@ -8777,7 +8487,7 @@
       </p:sp>
       <p:sp>
         <p:nvSpPr>
-          <p:cNvPr id="28" name="TextBox 27"/>
+          <p:cNvPr id="27" name="TextBox 26"/>
           <p:cNvSpPr txBox="1"/>
           <p:nvPr/>
         </p:nvSpPr>
@@ -8928,92 +8638,34 @@
           </a:p>
         </p:txBody>
       </p:sp>
-      <p:sp>
-        <p:nvSpPr>
-          <p:cNvPr id="4" name="Rectangle 3"/>
-          <p:cNvSpPr/>
-          <p:nvPr/>
-        </p:nvSpPr>
-        <p:spPr>
-          <a:xfrm>
-            <a:off x="9811512" y="365760"/>
-            <a:ext cx="1554480" cy="475488"/>
-          </a:xfrm>
-          <a:prstGeom prst="rect">
-            <a:avLst/>
-          </a:prstGeom>
-          <a:noFill/>
-          <a:ln w="9525">
-            <a:solidFill>
-              <a:srgbClr val="D4AF37">
-                <a:alpha val="45000"/>
-              </a:srgbClr>
-            </a:solidFill>
-          </a:ln>
+      <p:pic>
+        <p:nvPicPr>
+          <p:cNvPr id="4" name="Picture 3" descr="logo_white.png"/>
+          <p:cNvPicPr>
+            <a:picLocks noChangeAspect="1"/>
+          </p:cNvPicPr>
+          <p:nvPr/>
+        </p:nvPicPr>
+        <p:blipFill>
+          <a:blip r:embed="rId2"/>
+          <a:stretch>
+            <a:fillRect/>
+          </a:stretch>
+        </p:blipFill>
+        <p:spPr>
+          <a:xfrm>
+            <a:off x="11000232" y="384048"/>
+            <a:ext cx="365760" cy="365760"/>
+          </a:xfrm>
+          <a:prstGeom prst="rect">
+            <a:avLst/>
+          </a:prstGeom>
           <a:effectLst/>
         </p:spPr>
-        <p:style>
-          <a:lnRef idx="1">
-            <a:schemeClr val="accent1"/>
-          </a:lnRef>
-          <a:fillRef idx="3">
-            <a:schemeClr val="accent1"/>
-          </a:fillRef>
-          <a:effectRef idx="2">
-            <a:schemeClr val="accent1"/>
-          </a:effectRef>
-          <a:fontRef idx="minor">
-            <a:schemeClr val="lt1"/>
-          </a:fontRef>
-        </p:style>
-        <p:txBody>
-          <a:bodyPr rtlCol="0" anchor="ctr"/>
-          <a:lstStyle/>
-          <a:p>
-            <a:pPr algn="ctr"/>
-          </a:p>
-        </p:txBody>
-      </p:sp>
-      <p:sp>
-        <p:nvSpPr>
-          <p:cNvPr id="5" name="TextBox 4"/>
-          <p:cNvSpPr txBox="1"/>
-          <p:nvPr/>
-        </p:nvSpPr>
-        <p:spPr>
-          <a:xfrm>
-            <a:off x="9811512" y="365760"/>
-            <a:ext cx="1554480" cy="475488"/>
-          </a:xfrm>
-          <a:prstGeom prst="rect">
-            <a:avLst/>
-          </a:prstGeom>
-          <a:noFill/>
-        </p:spPr>
-        <p:txBody>
-          <a:bodyPr wrap="square" anchor="ctr" lIns="0" rIns="0" tIns="0" bIns="0">
-            <a:spAutoFit/>
-          </a:bodyPr>
-          <a:lstStyle/>
-          <a:p>
-            <a:pPr algn="ctr"/>
-            <a:r>
-              <a:rPr sz="750" b="1" spc="40000">
-                <a:solidFill>
-                  <a:srgbClr val="A0AEC0">
-                    <a:alpha val="85000"/>
-                  </a:srgbClr>
-                </a:solidFill>
-                <a:latin typeface="Montserrat"/>
-              </a:rPr>
-              <a:t>ЛОГОТИП</a:t>
-            </a:r>
-          </a:p>
-        </p:txBody>
-      </p:sp>
-      <p:sp>
-        <p:nvSpPr>
-          <p:cNvPr id="6" name="Rectangle 5"/>
+      </p:pic>
+      <p:sp>
+        <p:nvSpPr>
+          <p:cNvPr id="5" name="Rectangle 4"/>
           <p:cNvSpPr/>
           <p:nvPr/>
         </p:nvSpPr>
@@ -9059,7 +8711,7 @@
       </p:sp>
       <p:sp>
         <p:nvSpPr>
-          <p:cNvPr id="7" name="Rectangle 6"/>
+          <p:cNvPr id="6" name="Rectangle 5"/>
           <p:cNvSpPr/>
           <p:nvPr/>
         </p:nvSpPr>
@@ -9105,7 +8757,7 @@
       </p:sp>
       <p:sp>
         <p:nvSpPr>
-          <p:cNvPr id="8" name="TextBox 7"/>
+          <p:cNvPr id="7" name="TextBox 6"/>
           <p:cNvSpPr txBox="1"/>
           <p:nvPr/>
         </p:nvSpPr>
@@ -9142,7 +8794,7 @@
       </p:sp>
       <p:sp>
         <p:nvSpPr>
-          <p:cNvPr id="9" name="TextBox 8"/>
+          <p:cNvPr id="8" name="TextBox 7"/>
           <p:cNvSpPr txBox="1"/>
           <p:nvPr/>
         </p:nvSpPr>
@@ -9179,7 +8831,7 @@
       </p:sp>
       <p:sp>
         <p:nvSpPr>
-          <p:cNvPr id="10" name="TextBox 9"/>
+          <p:cNvPr id="9" name="TextBox 8"/>
           <p:cNvSpPr txBox="1"/>
           <p:nvPr/>
         </p:nvSpPr>
@@ -9216,7 +8868,7 @@
       </p:sp>
       <p:sp>
         <p:nvSpPr>
-          <p:cNvPr id="11" name="Diamond 10"/>
+          <p:cNvPr id="10" name="Diamond 9"/>
           <p:cNvSpPr/>
           <p:nvPr/>
         </p:nvSpPr>
@@ -9262,7 +8914,7 @@
       </p:sp>
       <p:sp>
         <p:nvSpPr>
-          <p:cNvPr id="12" name="TextBox 11"/>
+          <p:cNvPr id="11" name="TextBox 10"/>
           <p:cNvSpPr txBox="1"/>
           <p:nvPr/>
         </p:nvSpPr>
@@ -9297,7 +8949,7 @@
       </p:sp>
       <p:sp>
         <p:nvSpPr>
-          <p:cNvPr id="13" name="TextBox 12"/>
+          <p:cNvPr id="12" name="TextBox 11"/>
           <p:cNvSpPr txBox="1"/>
           <p:nvPr/>
         </p:nvSpPr>
@@ -9336,7 +8988,7 @@
       </p:sp>
       <p:sp>
         <p:nvSpPr>
-          <p:cNvPr id="14" name="TextBox 13"/>
+          <p:cNvPr id="13" name="TextBox 12"/>
           <p:cNvSpPr txBox="1"/>
           <p:nvPr/>
         </p:nvSpPr>
@@ -9375,7 +9027,7 @@
       </p:sp>
       <p:sp>
         <p:nvSpPr>
-          <p:cNvPr id="15" name="TextBox 14"/>
+          <p:cNvPr id="14" name="TextBox 13"/>
           <p:cNvSpPr txBox="1"/>
           <p:nvPr/>
         </p:nvSpPr>
@@ -9416,7 +9068,7 @@
       </p:sp>
       <p:sp>
         <p:nvSpPr>
-          <p:cNvPr id="16" name="Rectangle 15"/>
+          <p:cNvPr id="15" name="Rectangle 14"/>
           <p:cNvSpPr/>
           <p:nvPr/>
         </p:nvSpPr>
@@ -9462,7 +9114,7 @@
       </p:sp>
       <p:sp>
         <p:nvSpPr>
-          <p:cNvPr id="17" name="Oval 16"/>
+          <p:cNvPr id="16" name="Oval 15"/>
           <p:cNvSpPr/>
           <p:nvPr/>
         </p:nvSpPr>
@@ -9508,7 +9160,7 @@
       </p:sp>
       <p:sp>
         <p:nvSpPr>
-          <p:cNvPr id="18" name="Oval 17"/>
+          <p:cNvPr id="17" name="Oval 16"/>
           <p:cNvSpPr/>
           <p:nvPr/>
         </p:nvSpPr>
@@ -9552,7 +9204,7 @@
       </p:sp>
       <p:sp>
         <p:nvSpPr>
-          <p:cNvPr id="19" name="TextBox 18"/>
+          <p:cNvPr id="18" name="TextBox 17"/>
           <p:cNvSpPr txBox="1"/>
           <p:nvPr/>
         </p:nvSpPr>
@@ -9587,7 +9239,7 @@
       </p:sp>
       <p:sp>
         <p:nvSpPr>
-          <p:cNvPr id="20" name="TextBox 19"/>
+          <p:cNvPr id="19" name="TextBox 18"/>
           <p:cNvSpPr txBox="1"/>
           <p:nvPr/>
         </p:nvSpPr>
@@ -9622,7 +9274,7 @@
       </p:sp>
       <p:sp>
         <p:nvSpPr>
-          <p:cNvPr id="21" name="TextBox 20"/>
+          <p:cNvPr id="20" name="TextBox 19"/>
           <p:cNvSpPr txBox="1"/>
           <p:nvPr/>
         </p:nvSpPr>
@@ -9663,7 +9315,7 @@
       </p:sp>
       <p:sp>
         <p:nvSpPr>
-          <p:cNvPr id="22" name="TextBox 21"/>
+          <p:cNvPr id="21" name="TextBox 20"/>
           <p:cNvSpPr txBox="1"/>
           <p:nvPr/>
         </p:nvSpPr>
@@ -9700,7 +9352,7 @@
       </p:sp>
       <p:sp>
         <p:nvSpPr>
-          <p:cNvPr id="23" name="Oval 22"/>
+          <p:cNvPr id="22" name="Oval 21"/>
           <p:cNvSpPr/>
           <p:nvPr/>
         </p:nvSpPr>
@@ -9746,7 +9398,7 @@
       </p:sp>
       <p:sp>
         <p:nvSpPr>
-          <p:cNvPr id="24" name="Oval 23"/>
+          <p:cNvPr id="23" name="Oval 22"/>
           <p:cNvSpPr/>
           <p:nvPr/>
         </p:nvSpPr>
@@ -9790,7 +9442,7 @@
       </p:sp>
       <p:sp>
         <p:nvSpPr>
-          <p:cNvPr id="25" name="TextBox 24"/>
+          <p:cNvPr id="24" name="TextBox 23"/>
           <p:cNvSpPr txBox="1"/>
           <p:nvPr/>
         </p:nvSpPr>
@@ -9825,7 +9477,7 @@
       </p:sp>
       <p:sp>
         <p:nvSpPr>
-          <p:cNvPr id="26" name="TextBox 25"/>
+          <p:cNvPr id="25" name="TextBox 24"/>
           <p:cNvSpPr txBox="1"/>
           <p:nvPr/>
         </p:nvSpPr>
@@ -9860,7 +9512,7 @@
       </p:sp>
       <p:sp>
         <p:nvSpPr>
-          <p:cNvPr id="27" name="TextBox 26"/>
+          <p:cNvPr id="26" name="TextBox 25"/>
           <p:cNvSpPr txBox="1"/>
           <p:nvPr/>
         </p:nvSpPr>
@@ -9901,7 +9553,7 @@
       </p:sp>
       <p:sp>
         <p:nvSpPr>
-          <p:cNvPr id="28" name="TextBox 27"/>
+          <p:cNvPr id="27" name="TextBox 26"/>
           <p:cNvSpPr txBox="1"/>
           <p:nvPr/>
         </p:nvSpPr>
@@ -9938,7 +9590,7 @@
       </p:sp>
       <p:sp>
         <p:nvSpPr>
-          <p:cNvPr id="29" name="Oval 28"/>
+          <p:cNvPr id="28" name="Oval 27"/>
           <p:cNvSpPr/>
           <p:nvPr/>
         </p:nvSpPr>
@@ -9984,7 +9636,7 @@
       </p:sp>
       <p:sp>
         <p:nvSpPr>
-          <p:cNvPr id="30" name="Oval 29"/>
+          <p:cNvPr id="29" name="Oval 28"/>
           <p:cNvSpPr/>
           <p:nvPr/>
         </p:nvSpPr>
@@ -10028,7 +9680,7 @@
       </p:sp>
       <p:sp>
         <p:nvSpPr>
-          <p:cNvPr id="31" name="TextBox 30"/>
+          <p:cNvPr id="30" name="TextBox 29"/>
           <p:cNvSpPr txBox="1"/>
           <p:nvPr/>
         </p:nvSpPr>
@@ -10063,7 +9715,7 @@
       </p:sp>
       <p:sp>
         <p:nvSpPr>
-          <p:cNvPr id="32" name="TextBox 31"/>
+          <p:cNvPr id="31" name="TextBox 30"/>
           <p:cNvSpPr txBox="1"/>
           <p:nvPr/>
         </p:nvSpPr>
@@ -10098,7 +9750,7 @@
       </p:sp>
       <p:sp>
         <p:nvSpPr>
-          <p:cNvPr id="33" name="TextBox 32"/>
+          <p:cNvPr id="32" name="TextBox 31"/>
           <p:cNvSpPr txBox="1"/>
           <p:nvPr/>
         </p:nvSpPr>
@@ -10139,7 +9791,7 @@
       </p:sp>
       <p:sp>
         <p:nvSpPr>
-          <p:cNvPr id="34" name="TextBox 33"/>
+          <p:cNvPr id="33" name="TextBox 32"/>
           <p:cNvSpPr txBox="1"/>
           <p:nvPr/>
         </p:nvSpPr>
@@ -10176,7 +9828,7 @@
       </p:sp>
       <p:sp>
         <p:nvSpPr>
-          <p:cNvPr id="35" name="TextBox 34"/>
+          <p:cNvPr id="34" name="TextBox 33"/>
           <p:cNvSpPr txBox="1"/>
           <p:nvPr/>
         </p:nvSpPr>
@@ -10213,7 +9865,7 @@
       </p:sp>
       <p:sp>
         <p:nvSpPr>
-          <p:cNvPr id="36" name="TextBox 35"/>
+          <p:cNvPr id="35" name="TextBox 34"/>
           <p:cNvSpPr txBox="1"/>
           <p:nvPr/>
         </p:nvSpPr>
@@ -10366,92 +10018,34 @@
           </a:p>
         </p:txBody>
       </p:sp>
-      <p:sp>
-        <p:nvSpPr>
-          <p:cNvPr id="4" name="Rectangle 3"/>
-          <p:cNvSpPr/>
-          <p:nvPr/>
-        </p:nvSpPr>
-        <p:spPr>
-          <a:xfrm>
-            <a:off x="9811512" y="365760"/>
-            <a:ext cx="1554480" cy="475488"/>
-          </a:xfrm>
-          <a:prstGeom prst="rect">
-            <a:avLst/>
-          </a:prstGeom>
-          <a:noFill/>
-          <a:ln w="9525">
-            <a:solidFill>
-              <a:srgbClr val="D4AF37">
-                <a:alpha val="45000"/>
-              </a:srgbClr>
-            </a:solidFill>
-          </a:ln>
+      <p:pic>
+        <p:nvPicPr>
+          <p:cNvPr id="4" name="Picture 3" descr="logo_white.png"/>
+          <p:cNvPicPr>
+            <a:picLocks noChangeAspect="1"/>
+          </p:cNvPicPr>
+          <p:nvPr/>
+        </p:nvPicPr>
+        <p:blipFill>
+          <a:blip r:embed="rId2"/>
+          <a:stretch>
+            <a:fillRect/>
+          </a:stretch>
+        </p:blipFill>
+        <p:spPr>
+          <a:xfrm>
+            <a:off x="11000232" y="384048"/>
+            <a:ext cx="365760" cy="365760"/>
+          </a:xfrm>
+          <a:prstGeom prst="rect">
+            <a:avLst/>
+          </a:prstGeom>
           <a:effectLst/>
         </p:spPr>
-        <p:style>
-          <a:lnRef idx="1">
-            <a:schemeClr val="accent1"/>
-          </a:lnRef>
-          <a:fillRef idx="3">
-            <a:schemeClr val="accent1"/>
-          </a:fillRef>
-          <a:effectRef idx="2">
-            <a:schemeClr val="accent1"/>
-          </a:effectRef>
-          <a:fontRef idx="minor">
-            <a:schemeClr val="lt1"/>
-          </a:fontRef>
-        </p:style>
-        <p:txBody>
-          <a:bodyPr rtlCol="0" anchor="ctr"/>
-          <a:lstStyle/>
-          <a:p>
-            <a:pPr algn="ctr"/>
-          </a:p>
-        </p:txBody>
-      </p:sp>
-      <p:sp>
-        <p:nvSpPr>
-          <p:cNvPr id="5" name="TextBox 4"/>
-          <p:cNvSpPr txBox="1"/>
-          <p:nvPr/>
-        </p:nvSpPr>
-        <p:spPr>
-          <a:xfrm>
-            <a:off x="9811512" y="365760"/>
-            <a:ext cx="1554480" cy="475488"/>
-          </a:xfrm>
-          <a:prstGeom prst="rect">
-            <a:avLst/>
-          </a:prstGeom>
-          <a:noFill/>
-        </p:spPr>
-        <p:txBody>
-          <a:bodyPr wrap="square" anchor="ctr" lIns="0" rIns="0" tIns="0" bIns="0">
-            <a:spAutoFit/>
-          </a:bodyPr>
-          <a:lstStyle/>
-          <a:p>
-            <a:pPr algn="ctr"/>
-            <a:r>
-              <a:rPr sz="750" b="1" spc="40000">
-                <a:solidFill>
-                  <a:srgbClr val="A0AEC0">
-                    <a:alpha val="85000"/>
-                  </a:srgbClr>
-                </a:solidFill>
-                <a:latin typeface="Montserrat"/>
-              </a:rPr>
-              <a:t>ЛОГОТИП</a:t>
-            </a:r>
-          </a:p>
-        </p:txBody>
-      </p:sp>
-      <p:sp>
-        <p:nvSpPr>
-          <p:cNvPr id="6" name="Rectangle 5"/>
+      </p:pic>
+      <p:sp>
+        <p:nvSpPr>
+          <p:cNvPr id="5" name="Rectangle 4"/>
           <p:cNvSpPr/>
           <p:nvPr/>
         </p:nvSpPr>
@@ -10497,7 +10091,7 @@
       </p:sp>
       <p:sp>
         <p:nvSpPr>
-          <p:cNvPr id="7" name="Rectangle 6"/>
+          <p:cNvPr id="6" name="Rectangle 5"/>
           <p:cNvSpPr/>
           <p:nvPr/>
         </p:nvSpPr>
@@ -10543,7 +10137,7 @@
       </p:sp>
       <p:sp>
         <p:nvSpPr>
-          <p:cNvPr id="8" name="TextBox 7"/>
+          <p:cNvPr id="7" name="TextBox 6"/>
           <p:cNvSpPr txBox="1"/>
           <p:nvPr/>
         </p:nvSpPr>
@@ -10580,7 +10174,7 @@
       </p:sp>
       <p:sp>
         <p:nvSpPr>
-          <p:cNvPr id="9" name="TextBox 8"/>
+          <p:cNvPr id="8" name="TextBox 7"/>
           <p:cNvSpPr txBox="1"/>
           <p:nvPr/>
         </p:nvSpPr>
@@ -10617,7 +10211,7 @@
       </p:sp>
       <p:sp>
         <p:nvSpPr>
-          <p:cNvPr id="10" name="TextBox 9"/>
+          <p:cNvPr id="9" name="TextBox 8"/>
           <p:cNvSpPr txBox="1"/>
           <p:nvPr/>
         </p:nvSpPr>
@@ -10654,7 +10248,7 @@
       </p:sp>
       <p:sp>
         <p:nvSpPr>
-          <p:cNvPr id="11" name="Diamond 10"/>
+          <p:cNvPr id="10" name="Diamond 9"/>
           <p:cNvSpPr/>
           <p:nvPr/>
         </p:nvSpPr>
@@ -10700,7 +10294,7 @@
       </p:sp>
       <p:sp>
         <p:nvSpPr>
-          <p:cNvPr id="12" name="TextBox 11"/>
+          <p:cNvPr id="11" name="TextBox 10"/>
           <p:cNvSpPr txBox="1"/>
           <p:nvPr/>
         </p:nvSpPr>
@@ -10735,7 +10329,7 @@
       </p:sp>
       <p:sp>
         <p:nvSpPr>
-          <p:cNvPr id="13" name="TextBox 12"/>
+          <p:cNvPr id="12" name="TextBox 11"/>
           <p:cNvSpPr txBox="1"/>
           <p:nvPr/>
         </p:nvSpPr>
@@ -10774,7 +10368,7 @@
       </p:sp>
       <p:sp>
         <p:nvSpPr>
-          <p:cNvPr id="14" name="TextBox 13"/>
+          <p:cNvPr id="13" name="TextBox 12"/>
           <p:cNvSpPr txBox="1"/>
           <p:nvPr/>
         </p:nvSpPr>
@@ -10813,7 +10407,7 @@
       </p:sp>
       <p:sp>
         <p:nvSpPr>
-          <p:cNvPr id="15" name="Rounded Rectangle 14"/>
+          <p:cNvPr id="14" name="Rounded Rectangle 13"/>
           <p:cNvSpPr/>
           <p:nvPr/>
         </p:nvSpPr>
@@ -10865,7 +10459,7 @@
       </p:sp>
       <p:sp>
         <p:nvSpPr>
-          <p:cNvPr id="16" name="Rectangle 15"/>
+          <p:cNvPr id="15" name="Rectangle 14"/>
           <p:cNvSpPr/>
           <p:nvPr/>
         </p:nvSpPr>
@@ -10911,7 +10505,7 @@
       </p:sp>
       <p:sp>
         <p:nvSpPr>
-          <p:cNvPr id="17" name="TextBox 16"/>
+          <p:cNvPr id="16" name="TextBox 15"/>
           <p:cNvSpPr txBox="1"/>
           <p:nvPr/>
         </p:nvSpPr>
@@ -10946,7 +10540,7 @@
       </p:sp>
       <p:sp>
         <p:nvSpPr>
-          <p:cNvPr id="18" name="TextBox 17"/>
+          <p:cNvPr id="17" name="TextBox 16"/>
           <p:cNvSpPr txBox="1"/>
           <p:nvPr/>
         </p:nvSpPr>
@@ -10981,7 +10575,7 @@
       </p:sp>
       <p:sp>
         <p:nvSpPr>
-          <p:cNvPr id="19" name="TextBox 18"/>
+          <p:cNvPr id="18" name="TextBox 17"/>
           <p:cNvSpPr txBox="1"/>
           <p:nvPr/>
         </p:nvSpPr>
@@ -11022,7 +10616,7 @@
       </p:sp>
       <p:sp>
         <p:nvSpPr>
-          <p:cNvPr id="20" name="Rectangle 19"/>
+          <p:cNvPr id="19" name="Rectangle 18"/>
           <p:cNvSpPr/>
           <p:nvPr/>
         </p:nvSpPr>
@@ -11068,7 +10662,7 @@
       </p:sp>
       <p:sp>
         <p:nvSpPr>
-          <p:cNvPr id="21" name="TextBox 20"/>
+          <p:cNvPr id="20" name="TextBox 19"/>
           <p:cNvSpPr txBox="1"/>
           <p:nvPr/>
         </p:nvSpPr>
@@ -11225,92 +10819,34 @@
           </a:p>
         </p:txBody>
       </p:sp>
-      <p:sp>
-        <p:nvSpPr>
-          <p:cNvPr id="4" name="Rectangle 3"/>
-          <p:cNvSpPr/>
-          <p:nvPr/>
-        </p:nvSpPr>
-        <p:spPr>
-          <a:xfrm>
-            <a:off x="9811512" y="365760"/>
-            <a:ext cx="1554480" cy="475488"/>
-          </a:xfrm>
-          <a:prstGeom prst="rect">
-            <a:avLst/>
-          </a:prstGeom>
-          <a:noFill/>
-          <a:ln w="9525">
-            <a:solidFill>
-              <a:srgbClr val="D4AF37">
-                <a:alpha val="45000"/>
-              </a:srgbClr>
-            </a:solidFill>
-          </a:ln>
+      <p:pic>
+        <p:nvPicPr>
+          <p:cNvPr id="4" name="Picture 3" descr="logo_white.png"/>
+          <p:cNvPicPr>
+            <a:picLocks noChangeAspect="1"/>
+          </p:cNvPicPr>
+          <p:nvPr/>
+        </p:nvPicPr>
+        <p:blipFill>
+          <a:blip r:embed="rId2"/>
+          <a:stretch>
+            <a:fillRect/>
+          </a:stretch>
+        </p:blipFill>
+        <p:spPr>
+          <a:xfrm>
+            <a:off x="11000232" y="384048"/>
+            <a:ext cx="365760" cy="365760"/>
+          </a:xfrm>
+          <a:prstGeom prst="rect">
+            <a:avLst/>
+          </a:prstGeom>
           <a:effectLst/>
         </p:spPr>
-        <p:style>
-          <a:lnRef idx="1">
-            <a:schemeClr val="accent1"/>
-          </a:lnRef>
-          <a:fillRef idx="3">
-            <a:schemeClr val="accent1"/>
-          </a:fillRef>
-          <a:effectRef idx="2">
-            <a:schemeClr val="accent1"/>
-          </a:effectRef>
-          <a:fontRef idx="minor">
-            <a:schemeClr val="lt1"/>
-          </a:fontRef>
-        </p:style>
-        <p:txBody>
-          <a:bodyPr rtlCol="0" anchor="ctr"/>
-          <a:lstStyle/>
-          <a:p>
-            <a:pPr algn="ctr"/>
-          </a:p>
-        </p:txBody>
-      </p:sp>
-      <p:sp>
-        <p:nvSpPr>
-          <p:cNvPr id="5" name="TextBox 4"/>
-          <p:cNvSpPr txBox="1"/>
-          <p:nvPr/>
-        </p:nvSpPr>
-        <p:spPr>
-          <a:xfrm>
-            <a:off x="9811512" y="365760"/>
-            <a:ext cx="1554480" cy="475488"/>
-          </a:xfrm>
-          <a:prstGeom prst="rect">
-            <a:avLst/>
-          </a:prstGeom>
-          <a:noFill/>
-        </p:spPr>
-        <p:txBody>
-          <a:bodyPr wrap="square" anchor="ctr" lIns="0" rIns="0" tIns="0" bIns="0">
-            <a:spAutoFit/>
-          </a:bodyPr>
-          <a:lstStyle/>
-          <a:p>
-            <a:pPr algn="ctr"/>
-            <a:r>
-              <a:rPr sz="750" b="1" spc="40000">
-                <a:solidFill>
-                  <a:srgbClr val="A0AEC0">
-                    <a:alpha val="85000"/>
-                  </a:srgbClr>
-                </a:solidFill>
-                <a:latin typeface="Montserrat"/>
-              </a:rPr>
-              <a:t>ЛОГОТИП</a:t>
-            </a:r>
-          </a:p>
-        </p:txBody>
-      </p:sp>
-      <p:sp>
-        <p:nvSpPr>
-          <p:cNvPr id="6" name="Rectangle 5"/>
+      </p:pic>
+      <p:sp>
+        <p:nvSpPr>
+          <p:cNvPr id="5" name="Rectangle 4"/>
           <p:cNvSpPr/>
           <p:nvPr/>
         </p:nvSpPr>
@@ -11356,7 +10892,7 @@
       </p:sp>
       <p:sp>
         <p:nvSpPr>
-          <p:cNvPr id="7" name="Rectangle 6"/>
+          <p:cNvPr id="6" name="Rectangle 5"/>
           <p:cNvSpPr/>
           <p:nvPr/>
         </p:nvSpPr>
@@ -11402,7 +10938,7 @@
       </p:sp>
       <p:sp>
         <p:nvSpPr>
-          <p:cNvPr id="8" name="TextBox 7"/>
+          <p:cNvPr id="7" name="TextBox 6"/>
           <p:cNvSpPr txBox="1"/>
           <p:nvPr/>
         </p:nvSpPr>
@@ -11439,7 +10975,7 @@
       </p:sp>
       <p:sp>
         <p:nvSpPr>
-          <p:cNvPr id="9" name="TextBox 8"/>
+          <p:cNvPr id="8" name="TextBox 7"/>
           <p:cNvSpPr txBox="1"/>
           <p:nvPr/>
         </p:nvSpPr>
@@ -11476,7 +11012,7 @@
       </p:sp>
       <p:sp>
         <p:nvSpPr>
-          <p:cNvPr id="10" name="TextBox 9"/>
+          <p:cNvPr id="9" name="TextBox 8"/>
           <p:cNvSpPr txBox="1"/>
           <p:nvPr/>
         </p:nvSpPr>
@@ -11513,7 +11049,7 @@
       </p:sp>
       <p:sp>
         <p:nvSpPr>
-          <p:cNvPr id="11" name="Diamond 10"/>
+          <p:cNvPr id="10" name="Diamond 9"/>
           <p:cNvSpPr/>
           <p:nvPr/>
         </p:nvSpPr>
@@ -11559,7 +11095,7 @@
       </p:sp>
       <p:sp>
         <p:nvSpPr>
-          <p:cNvPr id="12" name="TextBox 11"/>
+          <p:cNvPr id="11" name="TextBox 10"/>
           <p:cNvSpPr txBox="1"/>
           <p:nvPr/>
         </p:nvSpPr>
@@ -11594,7 +11130,7 @@
       </p:sp>
       <p:sp>
         <p:nvSpPr>
-          <p:cNvPr id="13" name="TextBox 12"/>
+          <p:cNvPr id="12" name="TextBox 11"/>
           <p:cNvSpPr txBox="1"/>
           <p:nvPr/>
         </p:nvSpPr>
@@ -11633,7 +11169,7 @@
       </p:sp>
       <p:sp>
         <p:nvSpPr>
-          <p:cNvPr id="14" name="TextBox 13"/>
+          <p:cNvPr id="13" name="TextBox 12"/>
           <p:cNvSpPr txBox="1"/>
           <p:nvPr/>
         </p:nvSpPr>
@@ -11672,7 +11208,7 @@
       </p:sp>
       <p:sp>
         <p:nvSpPr>
-          <p:cNvPr id="15" name="Rounded Rectangle 14"/>
+          <p:cNvPr id="14" name="Rounded Rectangle 13"/>
           <p:cNvSpPr/>
           <p:nvPr/>
         </p:nvSpPr>
@@ -11724,7 +11260,7 @@
       </p:sp>
       <p:sp>
         <p:nvSpPr>
-          <p:cNvPr id="16" name="Rectangle 15"/>
+          <p:cNvPr id="15" name="Rectangle 14"/>
           <p:cNvSpPr/>
           <p:nvPr/>
         </p:nvSpPr>
@@ -11770,7 +11306,7 @@
       </p:sp>
       <p:sp>
         <p:nvSpPr>
-          <p:cNvPr id="17" name="TextBox 16"/>
+          <p:cNvPr id="16" name="TextBox 15"/>
           <p:cNvSpPr txBox="1"/>
           <p:nvPr/>
         </p:nvSpPr>
@@ -11805,7 +11341,7 @@
       </p:sp>
       <p:sp>
         <p:nvSpPr>
-          <p:cNvPr id="18" name="TextBox 17"/>
+          <p:cNvPr id="17" name="TextBox 16"/>
           <p:cNvSpPr txBox="1"/>
           <p:nvPr/>
         </p:nvSpPr>
@@ -11840,7 +11376,7 @@
       </p:sp>
       <p:sp>
         <p:nvSpPr>
-          <p:cNvPr id="19" name="TextBox 18"/>
+          <p:cNvPr id="18" name="TextBox 17"/>
           <p:cNvSpPr txBox="1"/>
           <p:nvPr/>
         </p:nvSpPr>
@@ -11881,7 +11417,7 @@
       </p:sp>
       <p:sp>
         <p:nvSpPr>
-          <p:cNvPr id="20" name="Rectangle 19"/>
+          <p:cNvPr id="19" name="Rectangle 18"/>
           <p:cNvSpPr/>
           <p:nvPr/>
         </p:nvSpPr>
@@ -11927,7 +11463,7 @@
       </p:sp>
       <p:sp>
         <p:nvSpPr>
-          <p:cNvPr id="21" name="TextBox 20"/>
+          <p:cNvPr id="20" name="TextBox 19"/>
           <p:cNvSpPr txBox="1"/>
           <p:nvPr/>
         </p:nvSpPr>
@@ -11964,7 +11500,7 @@
       </p:sp>
       <p:sp>
         <p:nvSpPr>
-          <p:cNvPr id="22" name="Rounded Rectangle 21"/>
+          <p:cNvPr id="21" name="Rounded Rectangle 20"/>
           <p:cNvSpPr/>
           <p:nvPr/>
         </p:nvSpPr>
@@ -12016,7 +11552,7 @@
       </p:sp>
       <p:sp>
         <p:nvSpPr>
-          <p:cNvPr id="23" name="Diamond 22"/>
+          <p:cNvPr id="22" name="Diamond 21"/>
           <p:cNvSpPr/>
           <p:nvPr/>
         </p:nvSpPr>
@@ -12062,7 +11598,7 @@
       </p:sp>
       <p:sp>
         <p:nvSpPr>
-          <p:cNvPr id="24" name="TextBox 23"/>
+          <p:cNvPr id="23" name="TextBox 22"/>
           <p:cNvSpPr txBox="1"/>
           <p:nvPr/>
         </p:nvSpPr>
@@ -12117,7 +11653,7 @@
       </p:sp>
       <p:sp>
         <p:nvSpPr>
-          <p:cNvPr id="25" name="Rectangle 24"/>
+          <p:cNvPr id="24" name="Rectangle 23"/>
           <p:cNvSpPr/>
           <p:nvPr/>
         </p:nvSpPr>
@@ -12163,7 +11699,7 @@
       </p:sp>
       <p:sp>
         <p:nvSpPr>
-          <p:cNvPr id="26" name="TextBox 25"/>
+          <p:cNvPr id="25" name="TextBox 24"/>
           <p:cNvSpPr txBox="1"/>
           <p:nvPr/>
         </p:nvSpPr>

</xml_diff>

<commit_message>
fix: embed Montserrat/Inter subsets into PPTX (identical rendering on any machine without the fonts)
Co-authored-by: arena-agent <297053741+arena-agent@users.noreply.github.com>
</commit_message>
<xml_diff>
--- a/presentation/preorder_new_year_corporate_2025.pptx
+++ b/presentation/preorder_new_year_corporate_2025.pptx
@@ -16,6 +16,24 @@
   </p:sldIdLst>
   <p:sldSz cx="12191695" cy="6858000" type="screen4x3"/>
   <p:notesSz cx="6858000" cy="9144000"/>
+  <p:embeddedFontLst>
+    <p:embeddedFont>
+      <p:font typeface="Montserrat" pitchFamily="34" charset="0"/>
+      <p:regular r:id="rId15"/>
+    </p:embeddedFont>
+    <p:embeddedFont>
+      <p:font typeface="Montserrat" pitchFamily="34" charset="0"/>
+      <p:bold r:id="rId16"/>
+    </p:embeddedFont>
+    <p:embeddedFont>
+      <p:font typeface="Inter" pitchFamily="34" charset="0"/>
+      <p:regular r:id="rId17"/>
+    </p:embeddedFont>
+    <p:embeddedFont>
+      <p:font typeface="Inter" pitchFamily="34" charset="0"/>
+      <p:bold r:id="rId18"/>
+    </p:embeddedFont>
+  </p:embeddedFontLst>
   <p:defaultTextStyle>
     <a:defPPr>
       <a:defRPr lang="en-US"/>
@@ -3720,6 +3738,8 @@
                   </a:srgbClr>
                 </a:solidFill>
                 <a:latin typeface="Montserrat"/>
+                <a:ea typeface="Montserrat"/>
+                <a:cs typeface="Montserrat"/>
               </a:rPr>
               <a:t>EXCLUSIVE PRE-BOOKING · WINTER 2024–2025</a:t>
             </a:r>
@@ -3759,6 +3779,8 @@
                   <a:srgbClr val="FFFFFF"/>
                 </a:solidFill>
                 <a:latin typeface="Montserrat"/>
+                <a:ea typeface="Montserrat"/>
+                <a:cs typeface="Montserrat"/>
               </a:rPr>
               <a:t>ПРЕДВАРИТЕЛЬНЫЙ ЗАКАЗ</a:t>
             </a:r>
@@ -3775,6 +3797,8 @@
                   <a:srgbClr val="FFFFFF"/>
                 </a:solidFill>
                 <a:latin typeface="Montserrat"/>
+                <a:ea typeface="Montserrat"/>
+                <a:cs typeface="Montserrat"/>
               </a:rPr>
               <a:t>НОВОГОДНЕГО КОРПОРАТИВА</a:t>
             </a:r>
@@ -3810,6 +3834,8 @@
                   <a:srgbClr val="E5C378"/>
                 </a:solidFill>
                 <a:latin typeface="Inter"/>
+                <a:ea typeface="Inter"/>
+                <a:cs typeface="Inter"/>
               </a:rPr>
               <a:t>7 причин зафиксировать идеальный финал года уже сейчас</a:t>
             </a:r>
@@ -3945,6 +3971,8 @@
                   </a:srgbClr>
                 </a:solidFill>
                 <a:latin typeface="Inter"/>
+                <a:ea typeface="Inter"/>
+                <a:cs typeface="Inter"/>
               </a:rPr>
               <a:t>МОСКВА   ·   СЕЗОН 2024–2025   ·   ЭКСКЛЮЗИВНОЕ ПРЕДЛОЖЕНИЕ ДЛЯ КОРПОРАТИВНЫХ КЛИЕНТОВ</a:t>
             </a:r>
@@ -4063,6 +4091,8 @@
                   </a:srgbClr>
                 </a:solidFill>
                 <a:latin typeface="Montserrat"/>
+                <a:ea typeface="Montserrat"/>
+                <a:cs typeface="Montserrat"/>
               </a:rPr>
               <a:t>МОСКВА · СЕЗОН 2024–2025</a:t>
             </a:r>
@@ -4217,6 +4247,8 @@
                   </a:srgbClr>
                 </a:solidFill>
                 <a:latin typeface="Inter"/>
+                <a:ea typeface="Inter"/>
+                <a:cs typeface="Inter"/>
               </a:rPr>
               <a:t>02 / 08</a:t>
             </a:r>
@@ -4254,6 +4286,8 @@
                   </a:srgbClr>
                 </a:solidFill>
                 <a:latin typeface="Inter"/>
+                <a:ea typeface="Inter"/>
+                <a:cs typeface="Inter"/>
               </a:rPr>
               <a:t>НОВОГОДНИЙ КОРПОРАТИВ · ПРЕДВАРИТЕЛЬНЫЙ ЗАКАЗ</a:t>
             </a:r>
@@ -4291,6 +4325,8 @@
                   </a:srgbClr>
                 </a:solidFill>
                 <a:latin typeface="Montserrat"/>
+                <a:ea typeface="Montserrat"/>
+                <a:cs typeface="Montserrat"/>
               </a:rPr>
               <a:t>01</a:t>
             </a:r>
@@ -4372,6 +4408,8 @@
                   <a:srgbClr val="E5C378"/>
                 </a:solidFill>
                 <a:latin typeface="Montserrat"/>
+                <a:ea typeface="Montserrat"/>
+                <a:cs typeface="Montserrat"/>
               </a:rPr>
               <a:t>ПРЕИМУЩЕСТВО 01 · ДОСТУП К ЭКСКЛЮЗИВУ</a:t>
             </a:r>
@@ -4411,6 +4449,8 @@
                   <a:srgbClr val="FFFFFF"/>
                 </a:solidFill>
                 <a:latin typeface="Montserrat"/>
+                <a:ea typeface="Montserrat"/>
+                <a:cs typeface="Montserrat"/>
               </a:rPr>
               <a:t>Лучшие площадки и даты</a:t>
             </a:r>
@@ -4450,6 +4490,8 @@
                   <a:srgbClr val="A0AEC0"/>
                 </a:solidFill>
                 <a:latin typeface="Inter"/>
+                <a:ea typeface="Inter"/>
+                <a:cs typeface="Inter"/>
               </a:rPr>
               <a:t>Успеваем перехватить «золотые даты» декабря и бронируем топовые залы столицы, пока весь бизнес стоит в листах ожидания. Никаких компромиссов: ваш корпоратив пройдет в идеальный вечер и на самой эффектной площадке Москвы.</a:t>
             </a:r>
@@ -4585,6 +4627,8 @@
                   </a:srgbClr>
                 </a:solidFill>
                 <a:latin typeface="Montserrat"/>
+                <a:ea typeface="Montserrat"/>
+                <a:cs typeface="Montserrat"/>
               </a:rPr>
               <a:t>ДЕКАБРЬ · ЗОЛОТЫЕ ДАТЫ</a:t>
             </a:r>
@@ -4674,6 +4718,8 @@
                   </a:srgbClr>
                 </a:solidFill>
                 <a:latin typeface="Inter"/>
+                <a:ea typeface="Inter"/>
+                <a:cs typeface="Inter"/>
               </a:rPr>
               <a:t>18.12</a:t>
             </a:r>
@@ -4763,6 +4809,8 @@
                   </a:srgbClr>
                 </a:solidFill>
                 <a:latin typeface="Inter"/>
+                <a:ea typeface="Inter"/>
+                <a:cs typeface="Inter"/>
               </a:rPr>
               <a:t>19.12</a:t>
             </a:r>
@@ -4852,6 +4900,8 @@
                   </a:srgbClr>
                 </a:solidFill>
                 <a:latin typeface="Inter"/>
+                <a:ea typeface="Inter"/>
+                <a:cs typeface="Inter"/>
               </a:rPr>
               <a:t>20.12</a:t>
             </a:r>
@@ -4941,6 +4991,8 @@
                   </a:srgbClr>
                 </a:solidFill>
                 <a:latin typeface="Inter"/>
+                <a:ea typeface="Inter"/>
+                <a:cs typeface="Inter"/>
               </a:rPr>
               <a:t>21.12</a:t>
             </a:r>
@@ -5030,6 +5082,8 @@
                   </a:srgbClr>
                 </a:solidFill>
                 <a:latin typeface="Inter"/>
+                <a:ea typeface="Inter"/>
+                <a:cs typeface="Inter"/>
               </a:rPr>
               <a:t>24.12</a:t>
             </a:r>
@@ -5119,6 +5173,8 @@
                   </a:srgbClr>
                 </a:solidFill>
                 <a:latin typeface="Inter"/>
+                <a:ea typeface="Inter"/>
+                <a:cs typeface="Inter"/>
               </a:rPr>
               <a:t>25.12</a:t>
             </a:r>
@@ -5208,6 +5264,8 @@
                   </a:srgbClr>
                 </a:solidFill>
                 <a:latin typeface="Inter"/>
+                <a:ea typeface="Inter"/>
+                <a:cs typeface="Inter"/>
               </a:rPr>
               <a:t>26.12</a:t>
             </a:r>
@@ -5295,6 +5353,8 @@
                   <a:srgbClr val="0A0F1D"/>
                 </a:solidFill>
                 <a:latin typeface="Inter"/>
+                <a:ea typeface="Inter"/>
+                <a:cs typeface="Inter"/>
               </a:rPr>
               <a:t>27.12</a:t>
             </a:r>
@@ -5336,6 +5396,8 @@
                   </a:srgbClr>
                 </a:solidFill>
                 <a:latin typeface="Inter"/>
+                <a:ea typeface="Inter"/>
+                <a:cs typeface="Inter"/>
               </a:rPr>
               <a:t>Топовые залы, лофты-иконки и террасы столицы — бронь уже в работе</a:t>
             </a:r>
@@ -5427,6 +5489,8 @@
                   <a:srgbClr val="E5C378"/>
                 </a:solidFill>
                 <a:latin typeface="Montserrat"/>
+                <a:ea typeface="Montserrat"/>
+                <a:cs typeface="Montserrat"/>
               </a:rPr>
               <a:t>ПРАЙМ-ТАЙМ ДЕКАБРЯ</a:t>
             </a:r>
@@ -5439,6 +5503,8 @@
                   <a:srgbClr val="E5C378"/>
                 </a:solidFill>
                 <a:latin typeface="Montserrat"/>
+                <a:ea typeface="Montserrat"/>
+                <a:cs typeface="Montserrat"/>
               </a:rPr>
               <a:t>ГАРАНТИРОВАН</a:t>
             </a:r>
@@ -5557,6 +5623,8 @@
                   </a:srgbClr>
                 </a:solidFill>
                 <a:latin typeface="Montserrat"/>
+                <a:ea typeface="Montserrat"/>
+                <a:cs typeface="Montserrat"/>
               </a:rPr>
               <a:t>МОСКВА · СЕЗОН 2024–2025</a:t>
             </a:r>
@@ -5711,6 +5779,8 @@
                   </a:srgbClr>
                 </a:solidFill>
                 <a:latin typeface="Inter"/>
+                <a:ea typeface="Inter"/>
+                <a:cs typeface="Inter"/>
               </a:rPr>
               <a:t>03 / 08</a:t>
             </a:r>
@@ -5748,6 +5818,8 @@
                   </a:srgbClr>
                 </a:solidFill>
                 <a:latin typeface="Inter"/>
+                <a:ea typeface="Inter"/>
+                <a:cs typeface="Inter"/>
               </a:rPr>
               <a:t>НОВОГОДНИЙ КОРПОРАТИВ · ПРЕДВАРИТЕЛЬНЫЙ ЗАКАЗ</a:t>
             </a:r>
@@ -5785,6 +5857,8 @@
                   </a:srgbClr>
                 </a:solidFill>
                 <a:latin typeface="Montserrat"/>
+                <a:ea typeface="Montserrat"/>
+                <a:cs typeface="Montserrat"/>
               </a:rPr>
               <a:t>02</a:t>
             </a:r>
@@ -5866,6 +5940,8 @@
                   <a:srgbClr val="E5C378"/>
                 </a:solidFill>
                 <a:latin typeface="Montserrat"/>
+                <a:ea typeface="Montserrat"/>
+                <a:cs typeface="Montserrat"/>
               </a:rPr>
               <a:t>ПРЕИМУЩЕСТВО 02 · ФИНАНСОВАЯ ОПТИМИЗАЦИЯ</a:t>
             </a:r>
@@ -5905,6 +5981,8 @@
                   <a:srgbClr val="FFFFFF"/>
                 </a:solidFill>
                 <a:latin typeface="Montserrat"/>
+                <a:ea typeface="Montserrat"/>
+                <a:cs typeface="Montserrat"/>
               </a:rPr>
               <a:t>Скидка 10% на любую площадку</a:t>
             </a:r>
@@ -5944,6 +6022,8 @@
                   <a:srgbClr val="A0AEC0"/>
                 </a:solidFill>
                 <a:latin typeface="Inter"/>
+                <a:ea typeface="Inter"/>
+                <a:cs typeface="Inter"/>
               </a:rPr>
               <a:t>В разгар декабрьского ценового безумия мы за счет партнерских квот срезаем 10% со стоимости аренды абсолютно любой локации. Вы забираете статусное пространство на пике высокого сезона с очень приятной экономией для бюджета.</a:t>
             </a:r>
@@ -6124,6 +6204,8 @@
                   </a:srgbClr>
                 </a:solidFill>
                 <a:latin typeface="Montserrat"/>
+                <a:ea typeface="Montserrat"/>
+                <a:cs typeface="Montserrat"/>
               </a:rPr>
               <a:t>ПАРТНЕРСКАЯ КВОТА</a:t>
             </a:r>
@@ -6159,6 +6241,8 @@
                   <a:srgbClr val="E5C378"/>
                 </a:solidFill>
                 <a:latin typeface="Montserrat"/>
+                <a:ea typeface="Montserrat"/>
+                <a:cs typeface="Montserrat"/>
               </a:rPr>
               <a:t>-10%</a:t>
             </a:r>
@@ -6194,6 +6278,8 @@
                   <a:srgbClr val="D4AF37"/>
                 </a:solidFill>
                 <a:latin typeface="Montserrat"/>
+                <a:ea typeface="Montserrat"/>
+                <a:cs typeface="Montserrat"/>
               </a:rPr>
               <a:t>НА АРЕНДУ</a:t>
             </a:r>
@@ -6231,6 +6317,8 @@
                   </a:srgbClr>
                 </a:solidFill>
                 <a:latin typeface="Inter"/>
+                <a:ea typeface="Inter"/>
+                <a:cs typeface="Inter"/>
               </a:rPr>
               <a:t>Любая локация · Высокий сезон · Без ограничений</a:t>
             </a:r>
@@ -6349,6 +6437,8 @@
                   </a:srgbClr>
                 </a:solidFill>
                 <a:latin typeface="Montserrat"/>
+                <a:ea typeface="Montserrat"/>
+                <a:cs typeface="Montserrat"/>
               </a:rPr>
               <a:t>МОСКВА · СЕЗОН 2024–2025</a:t>
             </a:r>
@@ -6503,6 +6593,8 @@
                   </a:srgbClr>
                 </a:solidFill>
                 <a:latin typeface="Inter"/>
+                <a:ea typeface="Inter"/>
+                <a:cs typeface="Inter"/>
               </a:rPr>
               <a:t>04 / 08</a:t>
             </a:r>
@@ -6540,6 +6632,8 @@
                   </a:srgbClr>
                 </a:solidFill>
                 <a:latin typeface="Inter"/>
+                <a:ea typeface="Inter"/>
+                <a:cs typeface="Inter"/>
               </a:rPr>
               <a:t>НОВОГОДНИЙ КОРПОРАТИВ · ПРЕДВАРИТЕЛЬНЫЙ ЗАКАЗ</a:t>
             </a:r>
@@ -6577,6 +6671,8 @@
                   </a:srgbClr>
                 </a:solidFill>
                 <a:latin typeface="Montserrat"/>
+                <a:ea typeface="Montserrat"/>
+                <a:cs typeface="Montserrat"/>
               </a:rPr>
               <a:t>03</a:t>
             </a:r>
@@ -6658,6 +6754,8 @@
                   <a:srgbClr val="E5C378"/>
                 </a:solidFill>
                 <a:latin typeface="Montserrat"/>
+                <a:ea typeface="Montserrat"/>
+                <a:cs typeface="Montserrat"/>
               </a:rPr>
               <a:t>ПРЕИМУЩЕСТВО 03 · КРЕАТИВ И РЕЖИССУРА</a:t>
             </a:r>
@@ -6697,6 +6795,8 @@
                   <a:srgbClr val="FFFFFF"/>
                 </a:solidFill>
                 <a:latin typeface="Montserrat"/>
+                <a:ea typeface="Montserrat"/>
+                <a:cs typeface="Montserrat"/>
               </a:rPr>
               <a:t>Написание 3-х вариантов подробной концепции мероприятия</a:t>
             </a:r>
@@ -6736,6 +6836,8 @@
                   <a:srgbClr val="A0AEC0"/>
                 </a:solidFill>
                 <a:latin typeface="Inter"/>
+                <a:ea typeface="Inter"/>
+                <a:cs typeface="Inter"/>
               </a:rPr>
               <a:t>Никаких банальных «голубых огоньков» — мы разработаем три уникальных авторских сценария, от иммерсивной зимней сказки до стильного светского бала в духе Met Gala. Вам останется лишь выбрать, какой вау-эффект ярче всего подчеркнет триумф компании в уходящем году.</a:t>
             </a:r>
@@ -6773,6 +6875,8 @@
                   </a:srgbClr>
                 </a:solidFill>
                 <a:latin typeface="Montserrat"/>
+                <a:ea typeface="Montserrat"/>
+                <a:cs typeface="Montserrat"/>
               </a:rPr>
               <a:t>ТРИ КОНЦЕПЦИИ · ОДИН ВАШ ВЫБОР</a:t>
             </a:r>
@@ -6906,6 +7010,8 @@
                   <a:srgbClr val="D4AF37"/>
                 </a:solidFill>
                 <a:latin typeface="Montserrat"/>
+                <a:ea typeface="Montserrat"/>
+                <a:cs typeface="Montserrat"/>
               </a:rPr>
               <a:t>01</a:t>
             </a:r>
@@ -6941,6 +7047,8 @@
                   <a:srgbClr val="FFFFFF"/>
                 </a:solidFill>
                 <a:latin typeface="Montserrat"/>
+                <a:ea typeface="Montserrat"/>
+                <a:cs typeface="Montserrat"/>
               </a:rPr>
               <a:t>Иммерсивное шоу</a:t>
             </a:r>
@@ -6978,6 +7086,8 @@
                   </a:srgbClr>
                 </a:solidFill>
                 <a:latin typeface="Inter"/>
+                <a:ea typeface="Inter"/>
+                <a:cs typeface="Inter"/>
               </a:rPr>
               <a:t>зимняя сказка · интерактивный формат</a:t>
             </a:r>
@@ -7111,6 +7221,8 @@
                   <a:srgbClr val="D4AF37"/>
                 </a:solidFill>
                 <a:latin typeface="Montserrat"/>
+                <a:ea typeface="Montserrat"/>
+                <a:cs typeface="Montserrat"/>
               </a:rPr>
               <a:t>02</a:t>
             </a:r>
@@ -7146,6 +7258,8 @@
                   <a:srgbClr val="FFFFFF"/>
                 </a:solidFill>
                 <a:latin typeface="Montserrat"/>
+                <a:ea typeface="Montserrat"/>
+                <a:cs typeface="Montserrat"/>
               </a:rPr>
               <a:t>Светский гала-ужин</a:t>
             </a:r>
@@ -7183,6 +7297,8 @@
                   </a:srgbClr>
                 </a:solidFill>
                 <a:latin typeface="Inter"/>
+                <a:ea typeface="Inter"/>
+                <a:cs typeface="Inter"/>
               </a:rPr>
               <a:t>бальный вечер в духе Met Gala</a:t>
             </a:r>
@@ -7316,6 +7432,8 @@
                   <a:srgbClr val="D4AF37"/>
                 </a:solidFill>
                 <a:latin typeface="Montserrat"/>
+                <a:ea typeface="Montserrat"/>
+                <a:cs typeface="Montserrat"/>
               </a:rPr>
               <a:t>03</a:t>
             </a:r>
@@ -7351,6 +7469,8 @@
                   <a:srgbClr val="FFFFFF"/>
                 </a:solidFill>
                 <a:latin typeface="Montserrat"/>
+                <a:ea typeface="Montserrat"/>
+                <a:cs typeface="Montserrat"/>
               </a:rPr>
               <a:t>Индивидуальный кастом</a:t>
             </a:r>
@@ -7388,6 +7508,8 @@
                   </a:srgbClr>
                 </a:solidFill>
                 <a:latin typeface="Inter"/>
+                <a:ea typeface="Inter"/>
+                <a:cs typeface="Inter"/>
               </a:rPr>
               <a:t>полностью авторский сценарий</a:t>
             </a:r>
@@ -7425,6 +7547,8 @@
                   </a:srgbClr>
                 </a:solidFill>
                 <a:latin typeface="Montserrat"/>
+                <a:ea typeface="Montserrat"/>
+                <a:cs typeface="Montserrat"/>
               </a:rPr>
               <a:t>ПРЕЗЕНТАЦИЯ ТРЁХ ВАРИАНТОВ — ВХОДИТ В ПРЕДЗАКАЗ</a:t>
             </a:r>
@@ -7543,6 +7667,8 @@
                   </a:srgbClr>
                 </a:solidFill>
                 <a:latin typeface="Montserrat"/>
+                <a:ea typeface="Montserrat"/>
+                <a:cs typeface="Montserrat"/>
               </a:rPr>
               <a:t>МОСКВА · СЕЗОН 2024–2025</a:t>
             </a:r>
@@ -7697,6 +7823,8 @@
                   </a:srgbClr>
                 </a:solidFill>
                 <a:latin typeface="Inter"/>
+                <a:ea typeface="Inter"/>
+                <a:cs typeface="Inter"/>
               </a:rPr>
               <a:t>05 / 08</a:t>
             </a:r>
@@ -7734,6 +7862,8 @@
                   </a:srgbClr>
                 </a:solidFill>
                 <a:latin typeface="Inter"/>
+                <a:ea typeface="Inter"/>
+                <a:cs typeface="Inter"/>
               </a:rPr>
               <a:t>НОВОГОДНИЙ КОРПОРАТИВ · ПРЕДВАРИТЕЛЬНЫЙ ЗАКАЗ</a:t>
             </a:r>
@@ -7771,6 +7901,8 @@
                   </a:srgbClr>
                 </a:solidFill>
                 <a:latin typeface="Montserrat"/>
+                <a:ea typeface="Montserrat"/>
+                <a:cs typeface="Montserrat"/>
               </a:rPr>
               <a:t>04</a:t>
             </a:r>
@@ -7852,6 +7984,8 @@
                   <a:srgbClr val="E5C378"/>
                 </a:solidFill>
                 <a:latin typeface="Montserrat"/>
+                <a:ea typeface="Montserrat"/>
+                <a:cs typeface="Montserrat"/>
               </a:rPr>
               <a:t>ПРЕИМУЩЕСТВО 04 · БЕЗОПАСНЫЙ СТАРТ</a:t>
             </a:r>
@@ -7891,6 +8025,8 @@
                   <a:srgbClr val="FFFFFF"/>
                 </a:solidFill>
                 <a:latin typeface="Montserrat"/>
+                <a:ea typeface="Montserrat"/>
+                <a:cs typeface="Montserrat"/>
               </a:rPr>
               <a:t>Предоплата всего 30% от суммы мероприятия</a:t>
             </a:r>
@@ -7930,6 +8066,8 @@
                   <a:srgbClr val="A0AEC0"/>
                 </a:solidFill>
                 <a:latin typeface="Inter"/>
+                <a:ea typeface="Inter"/>
+                <a:cs typeface="Inter"/>
               </a:rPr>
               <a:t>Зафиксируйте за собой безупречный праздник всего за треть стоимости и спокойно готовьтесь к финалу года. Вы бронируете лучших подрядчиков и артистов прямо сейчас, не замораживая оборотные средства компании.</a:t>
             </a:r>
@@ -8065,6 +8203,8 @@
                   </a:srgbClr>
                 </a:solidFill>
                 <a:latin typeface="Montserrat"/>
+                <a:ea typeface="Montserrat"/>
+                <a:cs typeface="Montserrat"/>
               </a:rPr>
               <a:t>СТРУКТУРА ФИКСАЦИИ БРОНИ</a:t>
             </a:r>
@@ -8100,6 +8240,8 @@
                   <a:srgbClr val="E5C378"/>
                 </a:solidFill>
                 <a:latin typeface="Montserrat"/>
+                <a:ea typeface="Montserrat"/>
+                <a:cs typeface="Montserrat"/>
               </a:rPr>
               <a:t>30%</a:t>
             </a:r>
@@ -8141,6 +8283,8 @@
                   </a:srgbClr>
                 </a:solidFill>
                 <a:latin typeface="Inter"/>
+                <a:ea typeface="Inter"/>
+                <a:cs typeface="Inter"/>
               </a:rPr>
               <a:t>достаточно, чтобы дата и площадка стали вашими</a:t>
             </a:r>
@@ -8318,6 +8462,8 @@
                   </a:srgbClr>
                 </a:solidFill>
                 <a:latin typeface="Inter"/>
+                <a:ea typeface="Inter"/>
+                <a:cs typeface="Inter"/>
               </a:rPr>
               <a:t>0</a:t>
             </a:r>
@@ -8353,6 +8499,8 @@
                   <a:srgbClr val="D4AF37"/>
                 </a:solidFill>
                 <a:latin typeface="Montserrat"/>
+                <a:ea typeface="Montserrat"/>
+                <a:cs typeface="Montserrat"/>
               </a:rPr>
               <a:t>30</a:t>
             </a:r>
@@ -8390,6 +8538,8 @@
                   </a:srgbClr>
                 </a:solidFill>
                 <a:latin typeface="Inter"/>
+                <a:ea typeface="Inter"/>
+                <a:cs typeface="Inter"/>
               </a:rPr>
               <a:t>100</a:t>
             </a:r>
@@ -8431,6 +8581,8 @@
                   </a:srgbClr>
                 </a:solidFill>
                 <a:latin typeface="Inter"/>
+                <a:ea typeface="Inter"/>
+                <a:cs typeface="Inter"/>
               </a:rPr>
               <a:t>Остальные 70% — по комфортному графику после утверждения концепции и подрядчиков.</a:t>
             </a:r>
@@ -8514,6 +8666,8 @@
                   <a:srgbClr val="E5C378"/>
                 </a:solidFill>
                 <a:latin typeface="Montserrat"/>
+                <a:ea typeface="Montserrat"/>
+                <a:cs typeface="Montserrat"/>
               </a:rPr>
               <a:t>БЕЗ ЗАМОРОЗКИ ОБОРОТНЫХ СРЕДСТВ</a:t>
             </a:r>
@@ -8632,6 +8786,8 @@
                   </a:srgbClr>
                 </a:solidFill>
                 <a:latin typeface="Montserrat"/>
+                <a:ea typeface="Montserrat"/>
+                <a:cs typeface="Montserrat"/>
               </a:rPr>
               <a:t>МОСКВА · СЕЗОН 2024–2025</a:t>
             </a:r>
@@ -8786,6 +8942,8 @@
                   </a:srgbClr>
                 </a:solidFill>
                 <a:latin typeface="Inter"/>
+                <a:ea typeface="Inter"/>
+                <a:cs typeface="Inter"/>
               </a:rPr>
               <a:t>06 / 08</a:t>
             </a:r>
@@ -8823,6 +8981,8 @@
                   </a:srgbClr>
                 </a:solidFill>
                 <a:latin typeface="Inter"/>
+                <a:ea typeface="Inter"/>
+                <a:cs typeface="Inter"/>
               </a:rPr>
               <a:t>НОВОГОДНИЙ КОРПОРАТИВ · ПРЕДВАРИТЕЛЬНЫЙ ЗАКАЗ</a:t>
             </a:r>
@@ -8860,6 +9020,8 @@
                   </a:srgbClr>
                 </a:solidFill>
                 <a:latin typeface="Montserrat"/>
+                <a:ea typeface="Montserrat"/>
+                <a:cs typeface="Montserrat"/>
               </a:rPr>
               <a:t>05</a:t>
             </a:r>
@@ -8941,6 +9103,8 @@
                   <a:srgbClr val="E5C378"/>
                 </a:solidFill>
                 <a:latin typeface="Montserrat"/>
+                <a:ea typeface="Montserrat"/>
+                <a:cs typeface="Montserrat"/>
               </a:rPr>
               <a:t>ПРЕИМУЩЕСТВО 05 · КОМФОРТ ДЛЯ БУХГАЛТЕРИИ</a:t>
             </a:r>
@@ -8980,6 +9144,8 @@
                   <a:srgbClr val="FFFFFF"/>
                 </a:solidFill>
                 <a:latin typeface="Montserrat"/>
+                <a:ea typeface="Montserrat"/>
+                <a:cs typeface="Montserrat"/>
               </a:rPr>
               <a:t>Удобный график платежей</a:t>
             </a:r>
@@ -9019,6 +9185,8 @@
                   <a:srgbClr val="A0AEC0"/>
                 </a:solidFill>
                 <a:latin typeface="Inter"/>
+                <a:ea typeface="Inter"/>
+                <a:cs typeface="Inter"/>
               </a:rPr>
               <a:t>Никаких кассовых разрывов перед закрытием финансового года: мы составим комфортный календарь траншей, синхронизированный с вашей бухгалтерией. Вы закрываете бюджет поэтапно, прозрачно и без предновогоднего стресса.</a:t>
             </a:r>
@@ -9060,6 +9228,8 @@
                   </a:srgbClr>
                 </a:solidFill>
                 <a:latin typeface="Montserrat"/>
+                <a:ea typeface="Montserrat"/>
+                <a:cs typeface="Montserrat"/>
               </a:rPr>
               <a:t>КАЛЕНДАРЬ ТРАНШЕЙ · СОГЛАСУЕМ С ВАШЕЙ БУХГАЛЕРИЕЙ</a:t>
             </a:r>
@@ -9231,6 +9401,8 @@
                   <a:srgbClr val="E5C378"/>
                 </a:solidFill>
                 <a:latin typeface="Montserrat"/>
+                <a:ea typeface="Montserrat"/>
+                <a:cs typeface="Montserrat"/>
               </a:rPr>
               <a:t>30%</a:t>
             </a:r>
@@ -9266,6 +9438,8 @@
                   <a:srgbClr val="FFFFFF"/>
                 </a:solidFill>
                 <a:latin typeface="Montserrat"/>
+                <a:ea typeface="Montserrat"/>
+                <a:cs typeface="Montserrat"/>
               </a:rPr>
               <a:t>Транш 1</a:t>
             </a:r>
@@ -9307,6 +9481,8 @@
                   </a:srgbClr>
                 </a:solidFill>
                 <a:latin typeface="Inter"/>
+                <a:ea typeface="Inter"/>
+                <a:cs typeface="Inter"/>
               </a:rPr>
               <a:t>фиксируем дату и площадку</a:t>
             </a:r>
@@ -9344,6 +9520,8 @@
                   </a:srgbClr>
                 </a:solidFill>
                 <a:latin typeface="Montserrat"/>
+                <a:ea typeface="Montserrat"/>
+                <a:cs typeface="Montserrat"/>
               </a:rPr>
               <a:t>СЕГОДНЯ</a:t>
             </a:r>
@@ -9469,6 +9647,8 @@
                   <a:srgbClr val="E5C378"/>
                 </a:solidFill>
                 <a:latin typeface="Montserrat"/>
+                <a:ea typeface="Montserrat"/>
+                <a:cs typeface="Montserrat"/>
               </a:rPr>
               <a:t>40%</a:t>
             </a:r>
@@ -9504,6 +9684,8 @@
                   <a:srgbClr val="FFFFFF"/>
                 </a:solidFill>
                 <a:latin typeface="Montserrat"/>
+                <a:ea typeface="Montserrat"/>
+                <a:cs typeface="Montserrat"/>
               </a:rPr>
               <a:t>Транш 2</a:t>
             </a:r>
@@ -9545,6 +9727,8 @@
                   </a:srgbClr>
                 </a:solidFill>
                 <a:latin typeface="Inter"/>
+                <a:ea typeface="Inter"/>
+                <a:cs typeface="Inter"/>
               </a:rPr>
               <a:t>сценарий и подрядчики</a:t>
             </a:r>
@@ -9582,6 +9766,8 @@
                   </a:srgbClr>
                 </a:solidFill>
                 <a:latin typeface="Montserrat"/>
+                <a:ea typeface="Montserrat"/>
+                <a:cs typeface="Montserrat"/>
               </a:rPr>
               <a:t>НОЯБРЬ</a:t>
             </a:r>
@@ -9707,6 +9893,8 @@
                   <a:srgbClr val="E5C378"/>
                 </a:solidFill>
                 <a:latin typeface="Montserrat"/>
+                <a:ea typeface="Montserrat"/>
+                <a:cs typeface="Montserrat"/>
               </a:rPr>
               <a:t>30%</a:t>
             </a:r>
@@ -9742,6 +9930,8 @@
                   <a:srgbClr val="FFFFFF"/>
                 </a:solidFill>
                 <a:latin typeface="Montserrat"/>
+                <a:ea typeface="Montserrat"/>
+                <a:cs typeface="Montserrat"/>
               </a:rPr>
               <a:t>Финал</a:t>
             </a:r>
@@ -9783,6 +9973,8 @@
                   </a:srgbClr>
                 </a:solidFill>
                 <a:latin typeface="Inter"/>
+                <a:ea typeface="Inter"/>
+                <a:cs typeface="Inter"/>
               </a:rPr>
               <a:t>полная готовность события</a:t>
             </a:r>
@@ -9820,6 +10012,8 @@
                   </a:srgbClr>
                 </a:solidFill>
                 <a:latin typeface="Montserrat"/>
+                <a:ea typeface="Montserrat"/>
+                <a:cs typeface="Montserrat"/>
               </a:rPr>
               <a:t>ДЕКАБРЬ</a:t>
             </a:r>
@@ -9857,6 +10051,8 @@
                   </a:srgbClr>
                 </a:solidFill>
                 <a:latin typeface="Inter"/>
+                <a:ea typeface="Inter"/>
+                <a:cs typeface="Inter"/>
               </a:rPr>
               <a:t>→</a:t>
             </a:r>
@@ -9894,6 +10090,8 @@
                   </a:srgbClr>
                 </a:solidFill>
                 <a:latin typeface="Inter"/>
+                <a:ea typeface="Inter"/>
+                <a:cs typeface="Inter"/>
               </a:rPr>
               <a:t>→</a:t>
             </a:r>
@@ -10012,6 +10210,8 @@
                   </a:srgbClr>
                 </a:solidFill>
                 <a:latin typeface="Montserrat"/>
+                <a:ea typeface="Montserrat"/>
+                <a:cs typeface="Montserrat"/>
               </a:rPr>
               <a:t>МОСКВА · СЕЗОН 2024–2025</a:t>
             </a:r>
@@ -10166,6 +10366,8 @@
                   </a:srgbClr>
                 </a:solidFill>
                 <a:latin typeface="Inter"/>
+                <a:ea typeface="Inter"/>
+                <a:cs typeface="Inter"/>
               </a:rPr>
               <a:t>07 / 08</a:t>
             </a:r>
@@ -10203,6 +10405,8 @@
                   </a:srgbClr>
                 </a:solidFill>
                 <a:latin typeface="Inter"/>
+                <a:ea typeface="Inter"/>
+                <a:cs typeface="Inter"/>
               </a:rPr>
               <a:t>НОВОГОДНИЙ КОРПОРАТИВ · ПРЕДВАРИТЕЛЬНЫЙ ЗАКАЗ</a:t>
             </a:r>
@@ -10240,6 +10444,8 @@
                   </a:srgbClr>
                 </a:solidFill>
                 <a:latin typeface="Montserrat"/>
+                <a:ea typeface="Montserrat"/>
+                <a:cs typeface="Montserrat"/>
               </a:rPr>
               <a:t>06</a:t>
             </a:r>
@@ -10321,6 +10527,8 @@
                   <a:srgbClr val="E5C378"/>
                 </a:solidFill>
                 <a:latin typeface="Montserrat"/>
+                <a:ea typeface="Montserrat"/>
+                <a:cs typeface="Montserrat"/>
               </a:rPr>
               <a:t>ПРЕИМУЩЕСТВО 06 · ПОДАРОК № 1 — ТИМБИЛДИНГ</a:t>
             </a:r>
@@ -10360,6 +10568,8 @@
                   <a:srgbClr val="FFFFFF"/>
                 </a:solidFill>
                 <a:latin typeface="Montserrat"/>
+                <a:ea typeface="Montserrat"/>
+                <a:cs typeface="Montserrat"/>
               </a:rPr>
               <a:t>Предварительное онлайн-командообразующее мероприятие в подарок</a:t>
             </a:r>
@@ -10399,6 +10609,8 @@
                   <a:srgbClr val="A0AEC0"/>
                 </a:solidFill>
                 <a:latin typeface="Inter"/>
+                <a:ea typeface="Inter"/>
+                <a:cs typeface="Inter"/>
               </a:rPr>
               <a:t>Дарим интерактивный онлайн-квиз или предновогодний стрим, который снимет напряжение от декабрьских дедлайнов и объединит даже удаленщиков. Это идеальный разогрев, который подарит команде праздничное настроение задолго до первого звона бокалов.</a:t>
             </a:r>
@@ -10532,6 +10744,8 @@
                   <a:srgbClr val="E5C378"/>
                 </a:solidFill>
                 <a:latin typeface="Montserrat"/>
+                <a:ea typeface="Montserrat"/>
+                <a:cs typeface="Montserrat"/>
               </a:rPr>
               <a:t>SPECIAL GIFT</a:t>
             </a:r>
@@ -10567,6 +10781,8 @@
                   <a:srgbClr val="FFFFFF"/>
                 </a:solidFill>
                 <a:latin typeface="Montserrat"/>
+                <a:ea typeface="Montserrat"/>
+                <a:cs typeface="Montserrat"/>
               </a:rPr>
               <a:t>0 ₽</a:t>
             </a:r>
@@ -10608,6 +10824,8 @@
                   </a:srgbClr>
                 </a:solidFill>
                 <a:latin typeface="Inter"/>
+                <a:ea typeface="Inter"/>
+                <a:cs typeface="Inter"/>
               </a:rPr>
               <a:t>Онлайн-квиз или предновогодний стрим — в подарок каждой команде</a:t>
             </a:r>
@@ -10695,6 +10913,8 @@
                   </a:srgbClr>
                 </a:solidFill>
                 <a:latin typeface="Montserrat"/>
+                <a:ea typeface="Montserrat"/>
+                <a:cs typeface="Montserrat"/>
               </a:rPr>
               <a:t>ИДЕАЛЬНЫЙ РАЗОГРЕВ · ДАЖЕ ДЛЯ УДАЛЁННЫХ КОМАНД</a:t>
             </a:r>
@@ -10813,6 +11033,8 @@
                   </a:srgbClr>
                 </a:solidFill>
                 <a:latin typeface="Montserrat"/>
+                <a:ea typeface="Montserrat"/>
+                <a:cs typeface="Montserrat"/>
               </a:rPr>
               <a:t>МОСКВА · СЕЗОН 2024–2025</a:t>
             </a:r>
@@ -10967,6 +11189,8 @@
                   </a:srgbClr>
                 </a:solidFill>
                 <a:latin typeface="Inter"/>
+                <a:ea typeface="Inter"/>
+                <a:cs typeface="Inter"/>
               </a:rPr>
               <a:t>08 / 08</a:t>
             </a:r>
@@ -11004,6 +11228,8 @@
                   </a:srgbClr>
                 </a:solidFill>
                 <a:latin typeface="Inter"/>
+                <a:ea typeface="Inter"/>
+                <a:cs typeface="Inter"/>
               </a:rPr>
               <a:t>НОВОГОДНИЙ КОРПОРАТИВ · ПРЕДВАРИТЕЛЬНЫЙ ЗАКАЗ</a:t>
             </a:r>
@@ -11041,6 +11267,8 @@
                   </a:srgbClr>
                 </a:solidFill>
                 <a:latin typeface="Montserrat"/>
+                <a:ea typeface="Montserrat"/>
+                <a:cs typeface="Montserrat"/>
               </a:rPr>
               <a:t>07</a:t>
             </a:r>
@@ -11122,6 +11350,8 @@
                   <a:srgbClr val="E5C378"/>
                 </a:solidFill>
                 <a:latin typeface="Montserrat"/>
+                <a:ea typeface="Montserrat"/>
+                <a:cs typeface="Montserrat"/>
               </a:rPr>
               <a:t>ПРЕИМУЩЕСТВО 07 · ПОДАРОК № 2 — ФИНАЛ</a:t>
             </a:r>
@@ -11161,6 +11391,8 @@
                   <a:srgbClr val="FFFFFF"/>
                 </a:solidFill>
                 <a:latin typeface="Montserrat"/>
+                <a:ea typeface="Montserrat"/>
+                <a:cs typeface="Montserrat"/>
               </a:rPr>
               <a:t>Авторский шоу-торт с логотипом компании в подарок</a:t>
             </a:r>
@@ -11200,6 +11432,8 @@
                   <a:srgbClr val="A0AEC0"/>
                 </a:solidFill>
                 <a:latin typeface="Inter"/>
+                <a:ea typeface="Inter"/>
+                <a:cs typeface="Inter"/>
               </a:rPr>
               <a:t>Эффектная сладкая кульминация под бой курантов — за наш счет: создадим эксклюзивный торт с корпоративной символикой от звездного шеф-кондитера. Это не просто роскошный десерт за успехи года, а главный герой праздничных сторис ваших сотрудников!</a:t>
             </a:r>
@@ -11333,6 +11567,8 @@
                   <a:srgbClr val="E5C378"/>
                 </a:solidFill>
                 <a:latin typeface="Montserrat"/>
+                <a:ea typeface="Montserrat"/>
+                <a:cs typeface="Montserrat"/>
               </a:rPr>
               <a:t>FINALE · 0 ₽</a:t>
             </a:r>
@@ -11368,6 +11604,8 @@
                   <a:srgbClr val="FFFFFF"/>
                 </a:solidFill>
                 <a:latin typeface="Montserrat"/>
+                <a:ea typeface="Montserrat"/>
+                <a:cs typeface="Montserrat"/>
               </a:rPr>
               <a:t>0 ₽</a:t>
             </a:r>
@@ -11409,6 +11647,8 @@
                   </a:srgbClr>
                 </a:solidFill>
                 <a:latin typeface="Inter"/>
+                <a:ea typeface="Inter"/>
+                <a:cs typeface="Inter"/>
               </a:rPr>
               <a:t>Авторский шоу-торт от звездного шеф-кондитера — с логотипом компании</a:t>
             </a:r>
@@ -11492,6 +11732,8 @@
                   </a:srgbClr>
                 </a:solidFill>
                 <a:latin typeface="Montserrat"/>
+                <a:ea typeface="Montserrat"/>
+                <a:cs typeface="Montserrat"/>
               </a:rPr>
               <a:t>ГЛАВНЫЙ ГЕРОЙ ПРАЗДНИЧНЫХ СТОРИС</a:t>
             </a:r>
@@ -11629,6 +11871,8 @@
                   <a:srgbClr val="FFFFFF"/>
                 </a:solidFill>
                 <a:latin typeface="Montserrat"/>
+                <a:ea typeface="Montserrat"/>
+                <a:cs typeface="Montserrat"/>
               </a:rPr>
               <a:t>ЗАБРОНИРУЙТЕ ВСТРЕЧУ И ПРЕЗЕНТАЦИЮ ТРЁХ КОНЦЕПЦИЙ</a:t>
             </a:r>
@@ -11645,6 +11889,8 @@
                   <a:srgbClr val="E5C378"/>
                 </a:solidFill>
                 <a:latin typeface="Montserrat"/>
+                <a:ea typeface="Montserrat"/>
+                <a:cs typeface="Montserrat"/>
               </a:rPr>
               <a:t>УЖЕ НА ЭТОЙ НЕДЕЛЕ</a:t>
             </a:r>
@@ -11732,6 +11978,8 @@
                   </a:srgbClr>
                 </a:solidFill>
                 <a:latin typeface="Inter"/>
+                <a:ea typeface="Inter"/>
+                <a:cs typeface="Inter"/>
               </a:rPr>
               <a:t>ТЕЛЕФОН · +7 900 000-00-00</a:t>
             </a:r>
@@ -11750,6 +11998,8 @@
                   </a:srgbClr>
                 </a:solidFill>
                 <a:latin typeface="Inter"/>
+                <a:ea typeface="Inter"/>
+                <a:cs typeface="Inter"/>
               </a:rPr>
               <a:t>ПОЧТА · HELLO@AGENCY.RU</a:t>
             </a:r>
@@ -11768,6 +12018,8 @@
                   </a:srgbClr>
                 </a:solidFill>
                 <a:latin typeface="Inter"/>
+                <a:ea typeface="Inter"/>
+                <a:cs typeface="Inter"/>
               </a:rPr>
               <a:t>TELEGRAM · @AGENCY</a:t>
             </a:r>

</xml_diff>